<commit_message>
Complete FSP hiring workflow and jury delivery
</commit_message>
<xml_diff>
--- a/docs/delivery/fsp-career.pptx
+++ b/docs/delivery/fsp-career.pptx
@@ -2,20 +2,23 @@
 <file path=ppt/presentation.xml><?xml version="1.0" encoding="utf-8"?>
 <p:presentation xmlns:p="http://schemas.openxmlformats.org/presentationml/2006/main">
   <p:sldMasterIdLst>
-    <p:sldMasterId xmlns:r="http://schemas.openxmlformats.org/officeDocument/2006/relationships" id="2147483648" r:id="R7fdd6d81cdd64dc7"/>
+    <p:sldMasterId xmlns:r="http://schemas.openxmlformats.org/officeDocument/2006/relationships" id="2147483648" r:id="Rccb1d9dbe9b24ba2"/>
   </p:sldMasterIdLst>
   <p:notesMasterIdLst>
-    <p:notesMasterId xmlns:r="http://schemas.openxmlformats.org/officeDocument/2006/relationships" r:id="R91571d344b724b8b"/>
+    <p:notesMasterId xmlns:r="http://schemas.openxmlformats.org/officeDocument/2006/relationships" r:id="R8fb91e6fe2bb4ef8"/>
   </p:notesMasterIdLst>
   <p:sldIdLst>
-    <p:sldId xmlns:r="http://schemas.openxmlformats.org/officeDocument/2006/relationships" id="256" r:id="R8d4e45ab46df42a0"/>
-    <p:sldId xmlns:r="http://schemas.openxmlformats.org/officeDocument/2006/relationships" id="257" r:id="R34e87af458e54204"/>
-    <p:sldId xmlns:r="http://schemas.openxmlformats.org/officeDocument/2006/relationships" id="258" r:id="R4bae6674663c4a10"/>
-    <p:sldId xmlns:r="http://schemas.openxmlformats.org/officeDocument/2006/relationships" id="259" r:id="Redc6f25e65084792"/>
-    <p:sldId xmlns:r="http://schemas.openxmlformats.org/officeDocument/2006/relationships" id="260" r:id="Rcef34145bcd2400c"/>
-    <p:sldId xmlns:r="http://schemas.openxmlformats.org/officeDocument/2006/relationships" id="261" r:id="R8bd0397212b14ed5"/>
-    <p:sldId xmlns:r="http://schemas.openxmlformats.org/officeDocument/2006/relationships" id="262" r:id="Rdaf0aa9b7c8a46a0"/>
-    <p:sldId xmlns:r="http://schemas.openxmlformats.org/officeDocument/2006/relationships" id="263" r:id="Re1b355625d944074"/>
+    <p:sldId xmlns:r="http://schemas.openxmlformats.org/officeDocument/2006/relationships" id="256" r:id="Rb7132f478af54249"/>
+    <p:sldId xmlns:r="http://schemas.openxmlformats.org/officeDocument/2006/relationships" id="257" r:id="R1cdcaeca8ae24b13"/>
+    <p:sldId xmlns:r="http://schemas.openxmlformats.org/officeDocument/2006/relationships" id="258" r:id="R9072b8b6a1ca42b2"/>
+    <p:sldId xmlns:r="http://schemas.openxmlformats.org/officeDocument/2006/relationships" id="259" r:id="Rd365078e9c9643ae"/>
+    <p:sldId xmlns:r="http://schemas.openxmlformats.org/officeDocument/2006/relationships" id="260" r:id="Ra07edf1ca0ee412e"/>
+    <p:sldId xmlns:r="http://schemas.openxmlformats.org/officeDocument/2006/relationships" id="261" r:id="R49e00d56495c453c"/>
+    <p:sldId xmlns:r="http://schemas.openxmlformats.org/officeDocument/2006/relationships" id="262" r:id="R4734581d64704a49"/>
+    <p:sldId xmlns:r="http://schemas.openxmlformats.org/officeDocument/2006/relationships" id="263" r:id="R52ee39ffb61c4dbe"/>
+    <p:sldId xmlns:r="http://schemas.openxmlformats.org/officeDocument/2006/relationships" id="264" r:id="R6caa6a7e8b0345ef"/>
+    <p:sldId xmlns:r="http://schemas.openxmlformats.org/officeDocument/2006/relationships" id="265" r:id="Rb699b015df9d41c5"/>
+    <p:sldId xmlns:r="http://schemas.openxmlformats.org/officeDocument/2006/relationships" id="266" r:id="Rdecec066f7fe491b"/>
   </p:sldIdLst>
   <p:sldSz cx="12192000" cy="6858000"/>
   <p:notesSz cx="6858000" cy="9144000"/>
@@ -479,6 +482,146 @@
 </p:notes>
 </file>
 
+<file path=ppt/notesSlides/notesSlide10.xml><?xml version="1.0" encoding="utf-8"?>
+<p:notes xmlns:p="http://schemas.openxmlformats.org/presentationml/2006/main">
+  <p:cSld>
+    <p:spTree>
+      <p:nvGrpSpPr>
+        <p:cNvPr id="1" name=""/>
+        <p:cNvGrpSpPr/>
+        <p:nvPr/>
+      </p:nvGrpSpPr>
+      <p:grpSpPr>
+        <a:xfrm xmlns:a="http://schemas.openxmlformats.org/drawingml/2006/main"/>
+      </p:grpSpPr>
+      <p:sp>
+        <p:nvSpPr>
+          <p:cNvPr id="2" name="Slide Image Placeholder 1"/>
+          <p:cNvSpPr>
+            <a:spLocks xmlns:a="http://schemas.openxmlformats.org/drawingml/2006/main" noGrp="1"/>
+          </p:cNvSpPr>
+          <p:nvPr>
+            <p:ph type="sldImg" idx="0"/>
+          </p:nvPr>
+        </p:nvSpPr>
+        <p:spPr/>
+      </p:sp>
+      <p:sp>
+        <p:nvSpPr>
+          <p:cNvPr id="3" name="Notes Placeholder 2"/>
+          <p:cNvSpPr>
+            <a:spLocks xmlns:a="http://schemas.openxmlformats.org/drawingml/2006/main" noGrp="1"/>
+          </p:cNvSpPr>
+          <p:nvPr>
+            <p:ph type="body" idx="1"/>
+          </p:nvPr>
+        </p:nvSpPr>
+        <p:spPr/>
+        <p:txBody>
+          <a:bodyPr xmlns:a="http://schemas.openxmlformats.org/drawingml/2006/main"/>
+          <a:lstStyle xmlns:a="http://schemas.openxmlformats.org/drawingml/2006/main"/>
+          <a:p xmlns:a="http://schemas.openxmlformats.org/drawingml/2006/main">
+            <a:r>
+              <a:t>Источник: backend/go.mod, frontend/package.json, compose.yaml и docs/architecture.md. Redis хранит сессии и счётчики. PostgreSQL хранит предметные данные, дедлайны и правила смены категории. Модульный монолит.</a:t>
+            </a:r>
+          </a:p>
+        </p:txBody>
+      </p:sp>
+      <p:sp>
+        <p:nvSpPr>
+          <p:cNvPr id="4" name="Slide Number Placeholder 3"/>
+          <p:cNvSpPr>
+            <a:spLocks xmlns:a="http://schemas.openxmlformats.org/drawingml/2006/main" noGrp="1"/>
+          </p:cNvSpPr>
+          <p:nvPr>
+            <p:ph type="sldNum" idx="5"/>
+          </p:nvPr>
+        </p:nvSpPr>
+        <p:spPr/>
+        <p:txBody>
+          <a:bodyPr xmlns:a="http://schemas.openxmlformats.org/drawingml/2006/main"/>
+          <a:lstStyle xmlns:a="http://schemas.openxmlformats.org/drawingml/2006/main"/>
+          <a:p xmlns:a="http://schemas.openxmlformats.org/drawingml/2006/main"/>
+        </p:txBody>
+      </p:sp>
+    </p:spTree>
+  </p:cSld>
+  <p:clrMapOvr>
+    <a:masterClrMapping xmlns:a="http://schemas.openxmlformats.org/drawingml/2006/main"/>
+  </p:clrMapOvr>
+</p:notes>
+</file>
+
+<file path=ppt/notesSlides/notesSlide11.xml><?xml version="1.0" encoding="utf-8"?>
+<p:notes xmlns:p="http://schemas.openxmlformats.org/presentationml/2006/main">
+  <p:cSld>
+    <p:spTree>
+      <p:nvGrpSpPr>
+        <p:cNvPr id="1" name=""/>
+        <p:cNvGrpSpPr/>
+        <p:nvPr/>
+      </p:nvGrpSpPr>
+      <p:grpSpPr>
+        <a:xfrm xmlns:a="http://schemas.openxmlformats.org/drawingml/2006/main"/>
+      </p:grpSpPr>
+      <p:sp>
+        <p:nvSpPr>
+          <p:cNvPr id="2" name="Slide Image Placeholder 1"/>
+          <p:cNvSpPr>
+            <a:spLocks xmlns:a="http://schemas.openxmlformats.org/drawingml/2006/main" noGrp="1"/>
+          </p:cNvSpPr>
+          <p:nvPr>
+            <p:ph type="sldImg" idx="0"/>
+          </p:nvPr>
+        </p:nvSpPr>
+        <p:spPr/>
+      </p:sp>
+      <p:sp>
+        <p:nvSpPr>
+          <p:cNvPr id="3" name="Notes Placeholder 2"/>
+          <p:cNvSpPr>
+            <a:spLocks xmlns:a="http://schemas.openxmlformats.org/drawingml/2006/main" noGrp="1"/>
+          </p:cNvSpPr>
+          <p:nvPr>
+            <p:ph type="body" idx="1"/>
+          </p:nvPr>
+        </p:nvSpPr>
+        <p:spPr/>
+        <p:txBody>
+          <a:bodyPr xmlns:a="http://schemas.openxmlformats.org/drawingml/2006/main"/>
+          <a:lstStyle xmlns:a="http://schemas.openxmlformats.org/drawingml/2006/main"/>
+          <a:p xmlns:a="http://schemas.openxmlformats.org/drawingml/2006/main">
+            <a:r>
+              <a:t>Источник: docs/architecture.md и ограничения README.md. Реальный API ФСП отсутствует в исходном ТЗ. OIDC/Keycloak, ATS и проверки работодателей являются предложенной концепцией. Нет подключённого внешнего LLM.</a:t>
+            </a:r>
+          </a:p>
+        </p:txBody>
+      </p:sp>
+      <p:sp>
+        <p:nvSpPr>
+          <p:cNvPr id="4" name="Slide Number Placeholder 3"/>
+          <p:cNvSpPr>
+            <a:spLocks xmlns:a="http://schemas.openxmlformats.org/drawingml/2006/main" noGrp="1"/>
+          </p:cNvSpPr>
+          <p:nvPr>
+            <p:ph type="sldNum" idx="5"/>
+          </p:nvPr>
+        </p:nvSpPr>
+        <p:spPr/>
+        <p:txBody>
+          <a:bodyPr xmlns:a="http://schemas.openxmlformats.org/drawingml/2006/main"/>
+          <a:lstStyle xmlns:a="http://schemas.openxmlformats.org/drawingml/2006/main"/>
+          <a:p xmlns:a="http://schemas.openxmlformats.org/drawingml/2006/main"/>
+        </p:txBody>
+      </p:sp>
+    </p:spTree>
+  </p:cSld>
+  <p:clrMapOvr>
+    <a:masterClrMapping xmlns:a="http://schemas.openxmlformats.org/drawingml/2006/main"/>
+  </p:clrMapOvr>
+</p:notes>
+</file>
+
 <file path=ppt/notesSlides/notesSlide2.xml><?xml version="1.0" encoding="utf-8"?>
 <p:notes xmlns:p="http://schemas.openxmlformats.org/presentationml/2006/main">
   <p:cSld>
@@ -729,7 +872,7 @@
           <a:lstStyle xmlns:a="http://schemas.openxmlformats.org/drawingml/2006/main"/>
           <a:p xmlns:a="http://schemas.openxmlformats.org/drawingml/2006/main">
             <a:r>
-              <a:t>Источник изображения: собственный скриншот приложения output/playwright/employer-desktop.png. Данные синтетические. Локальное приложение http://localhost:8080.</a:t>
+              <a:t>Источник изображения: собственный скриншот приложения output/playwright/employer-overview.png. Данные синтетические. Локальное приложение http://localhost:8080.</a:t>
             </a:r>
           </a:p>
         </p:txBody>
@@ -799,7 +942,7 @@
           <a:lstStyle xmlns:a="http://schemas.openxmlformats.org/drawingml/2006/main"/>
           <a:p xmlns:a="http://schemas.openxmlformats.org/drawingml/2006/main">
             <a:r>
-              <a:t>Источник: docs/assessment-validation.json, cmd/evaluate. По 100 новых seed=2..101 на девять категорий. Копирование ключа seed=1 без решения новых условий. Это механическая синтетическая проверка, не оценка реальных грейдов или устойчивости к помощи LLM.</a:t>
+              <a:t>Источник: собственный скриншот output/playwright/candidate-comparison.png. Демонстрационные профили. Совпадение стека опирается на самоописание, общая категория подтверждается тестом.</a:t>
             </a:r>
           </a:p>
         </p:txBody>
@@ -869,7 +1012,7 @@
           <a:lstStyle xmlns:a="http://schemas.openxmlformats.org/drawingml/2006/main"/>
           <a:p xmlns:a="http://schemas.openxmlformats.org/drawingml/2006/main">
             <a:r>
-              <a:t>Источник: backend/go.mod, frontend/package.json, compose.yaml и docs/architecture.md. Redis хранит сессии и счётчики. PostgreSQL хранит предметные данные, дедлайны и правила смены категории. Модульный монолит.</a:t>
+              <a:t>Источник: docs/assessment-validation.json, cmd/evaluate. По 100 новых seed=2..101 на девять категорий. Копирование ключа seed=1 без решения новых условий. Это механическая синтетическая проверка, не оценка реальных грейдов или устойчивости к помощи LLM.</a:t>
             </a:r>
           </a:p>
         </p:txBody>
@@ -939,7 +1082,77 @@
           <a:lstStyle xmlns:a="http://schemas.openxmlformats.org/drawingml/2006/main"/>
           <a:p xmlns:a="http://schemas.openxmlformats.org/drawingml/2006/main">
             <a:r>
-              <a:t>Источник: docs/architecture.md и ограничения README.md. Реальный API ФСП отсутствует в исходном ТЗ. OIDC/Keycloak, ATS и проверки работодателей являются предложенной концепцией. Нет подключённого внешнего LLM.</a:t>
+              <a:t>Источники: docs/matching-dataset.json, docs/matching-validation.json, docs/matching-http-validation.json. 12 синтетических профилей и 15 запросов. k=1,2,3. Одинаковые фильтры категории для основного алгоритма и базовых вариантов. Ручная разметка на данных разработки, без независимой проверки. HTTP-прогон воспроизводит результат.</a:t>
+            </a:r>
+          </a:p>
+        </p:txBody>
+      </p:sp>
+      <p:sp>
+        <p:nvSpPr>
+          <p:cNvPr id="4" name="Slide Number Placeholder 3"/>
+          <p:cNvSpPr>
+            <a:spLocks xmlns:a="http://schemas.openxmlformats.org/drawingml/2006/main" noGrp="1"/>
+          </p:cNvSpPr>
+          <p:nvPr>
+            <p:ph type="sldNum" idx="5"/>
+          </p:nvPr>
+        </p:nvSpPr>
+        <p:spPr/>
+        <p:txBody>
+          <a:bodyPr xmlns:a="http://schemas.openxmlformats.org/drawingml/2006/main"/>
+          <a:lstStyle xmlns:a="http://schemas.openxmlformats.org/drawingml/2006/main"/>
+          <a:p xmlns:a="http://schemas.openxmlformats.org/drawingml/2006/main"/>
+        </p:txBody>
+      </p:sp>
+    </p:spTree>
+  </p:cSld>
+  <p:clrMapOvr>
+    <a:masterClrMapping xmlns:a="http://schemas.openxmlformats.org/drawingml/2006/main"/>
+  </p:clrMapOvr>
+</p:notes>
+</file>
+
+<file path=ppt/notesSlides/notesSlide9.xml><?xml version="1.0" encoding="utf-8"?>
+<p:notes xmlns:p="http://schemas.openxmlformats.org/presentationml/2006/main">
+  <p:cSld>
+    <p:spTree>
+      <p:nvGrpSpPr>
+        <p:cNvPr id="1" name=""/>
+        <p:cNvGrpSpPr/>
+        <p:nvPr/>
+      </p:nvGrpSpPr>
+      <p:grpSpPr>
+        <a:xfrm xmlns:a="http://schemas.openxmlformats.org/drawingml/2006/main"/>
+      </p:grpSpPr>
+      <p:sp>
+        <p:nvSpPr>
+          <p:cNvPr id="2" name="Slide Image Placeholder 1"/>
+          <p:cNvSpPr>
+            <a:spLocks xmlns:a="http://schemas.openxmlformats.org/drawingml/2006/main" noGrp="1"/>
+          </p:cNvSpPr>
+          <p:nvPr>
+            <p:ph type="sldImg" idx="0"/>
+          </p:nvPr>
+        </p:nvSpPr>
+        <p:spPr/>
+      </p:sp>
+      <p:sp>
+        <p:nvSpPr>
+          <p:cNvPr id="3" name="Notes Placeholder 2"/>
+          <p:cNvSpPr>
+            <a:spLocks xmlns:a="http://schemas.openxmlformats.org/drawingml/2006/main" noGrp="1"/>
+          </p:cNvSpPr>
+          <p:nvPr>
+            <p:ph type="body" idx="1"/>
+          </p:nvPr>
+        </p:nvSpPr>
+        <p:spPr/>
+        <p:txBody>
+          <a:bodyPr xmlns:a="http://schemas.openxmlformats.org/drawingml/2006/main"/>
+          <a:lstStyle xmlns:a="http://schemas.openxmlformats.org/drawingml/2006/main"/>
+          <a:p xmlns:a="http://schemas.openxmlformats.org/drawingml/2006/main">
+            <a:r>
+              <a:t>Источник: собственный скриншот output/playwright/vacancies-employer.png, backend/internal/app/vacancies.go. Контакты открываются только компании с действующим откликом, отзыв снимает это основание доступа.</a:t>
             </a:r>
           </a:p>
         </p:txBody>
@@ -986,7 +1199,7 @@
           <p:cNvPr id="3" name="Title">
             <a:extLst xmlns:a="http://schemas.openxmlformats.org/drawingml/2006/main">
               <a:ext uri="{FF2B5EF4-FFF2-40B4-BE49-F238E27FC236}">
-                <a16:creationId xmlns:a16="http://schemas.microsoft.com/office/drawing/2014/main" id="{7899C964-F4C5-437A-8B7A-14C0EEE019AE}"/>
+                <a16:creationId xmlns:a16="http://schemas.microsoft.com/office/drawing/2014/main" id="{3DB8D80A-9224-446E-A044-E50E90BF9435}"/>
               </a:ext>
             </a:extLst>
           </p:cNvPr>
@@ -1143,7 +1356,7 @@
           <p:cNvPr id="2" name="Subtitle">
             <a:extLst xmlns:a="http://schemas.openxmlformats.org/drawingml/2006/main">
               <a:ext uri="{FF2B5EF4-FFF2-40B4-BE49-F238E27FC236}">
-                <a16:creationId xmlns:a16="http://schemas.microsoft.com/office/drawing/2014/main" id="{5538C0A6-563D-40AD-AB62-B7ABB2BF7625}"/>
+                <a16:creationId xmlns:a16="http://schemas.microsoft.com/office/drawing/2014/main" id="{BCF85F59-7DF4-4516-A6BB-408B9E3938C4}"/>
               </a:ext>
             </a:extLst>
           </p:cNvPr>
@@ -1317,7 +1530,7 @@
           <p:cNvPr id="2" name="Section title">
             <a:extLst xmlns:a="http://schemas.openxmlformats.org/drawingml/2006/main">
               <a:ext uri="{FF2B5EF4-FFF2-40B4-BE49-F238E27FC236}">
-                <a16:creationId xmlns:a16="http://schemas.microsoft.com/office/drawing/2014/main" id="{6452148B-194A-4D97-B11A-C0B74E16E554}"/>
+                <a16:creationId xmlns:a16="http://schemas.microsoft.com/office/drawing/2014/main" id="{CB5983F4-E531-44BE-8DB8-B493D4BFE6AB}"/>
               </a:ext>
             </a:extLst>
           </p:cNvPr>
@@ -1491,7 +1704,7 @@
           <p:cNvPr id="3" name="Title">
             <a:extLst xmlns:a="http://schemas.openxmlformats.org/drawingml/2006/main">
               <a:ext uri="{FF2B5EF4-FFF2-40B4-BE49-F238E27FC236}">
-                <a16:creationId xmlns:a16="http://schemas.microsoft.com/office/drawing/2014/main" id="{DCD06512-D954-40B4-83B7-B4054DD063A8}"/>
+                <a16:creationId xmlns:a16="http://schemas.microsoft.com/office/drawing/2014/main" id="{28A913BF-78E5-4E49-AA21-2879D1829031}"/>
               </a:ext>
             </a:extLst>
           </p:cNvPr>
@@ -1648,7 +1861,7 @@
           <p:cNvPr id="2" name="Body">
             <a:extLst xmlns:a="http://schemas.openxmlformats.org/drawingml/2006/main">
               <a:ext uri="{FF2B5EF4-FFF2-40B4-BE49-F238E27FC236}">
-                <a16:creationId xmlns:a16="http://schemas.microsoft.com/office/drawing/2014/main" id="{1958AA93-6931-4C1B-8D80-8BBFF4484969}"/>
+                <a16:creationId xmlns:a16="http://schemas.microsoft.com/office/drawing/2014/main" id="{A1964C8B-5247-4073-BB8A-110E9AA36E9A}"/>
               </a:ext>
             </a:extLst>
           </p:cNvPr>
@@ -1822,7 +2035,7 @@
           <p:cNvPr id="4" name="Title">
             <a:extLst xmlns:a="http://schemas.openxmlformats.org/drawingml/2006/main">
               <a:ext uri="{FF2B5EF4-FFF2-40B4-BE49-F238E27FC236}">
-                <a16:creationId xmlns:a16="http://schemas.microsoft.com/office/drawing/2014/main" id="{7E59C8C0-3742-4204-B41F-F827A2CD3169}"/>
+                <a16:creationId xmlns:a16="http://schemas.microsoft.com/office/drawing/2014/main" id="{DFBB30AA-FF69-42B0-ABC7-2CB57CDA5CFD}"/>
               </a:ext>
             </a:extLst>
           </p:cNvPr>
@@ -1979,7 +2192,7 @@
           <p:cNvPr id="2" name="Left column">
             <a:extLst xmlns:a="http://schemas.openxmlformats.org/drawingml/2006/main">
               <a:ext uri="{FF2B5EF4-FFF2-40B4-BE49-F238E27FC236}">
-                <a16:creationId xmlns:a16="http://schemas.microsoft.com/office/drawing/2014/main" id="{831F8AF1-C297-4AB8-8F91-5D9C1BC610FC}"/>
+                <a16:creationId xmlns:a16="http://schemas.microsoft.com/office/drawing/2014/main" id="{2238E45A-921C-49AE-A0B8-57F1F6536F86}"/>
               </a:ext>
             </a:extLst>
           </p:cNvPr>
@@ -2136,7 +2349,7 @@
           <p:cNvPr id="3" name="Right column">
             <a:extLst xmlns:a="http://schemas.openxmlformats.org/drawingml/2006/main">
               <a:ext uri="{FF2B5EF4-FFF2-40B4-BE49-F238E27FC236}">
-                <a16:creationId xmlns:a16="http://schemas.microsoft.com/office/drawing/2014/main" id="{07A44592-C905-49AE-9868-2F6BF01B89DC}"/>
+                <a16:creationId xmlns:a16="http://schemas.microsoft.com/office/drawing/2014/main" id="{8F0041BA-E688-47F3-8E59-BD642AC3B48D}"/>
               </a:ext>
             </a:extLst>
           </p:cNvPr>
@@ -2310,7 +2523,7 @@
           <p:cNvPr id="3" name="Title">
             <a:extLst xmlns:a="http://schemas.openxmlformats.org/drawingml/2006/main">
               <a:ext uri="{FF2B5EF4-FFF2-40B4-BE49-F238E27FC236}">
-                <a16:creationId xmlns:a16="http://schemas.microsoft.com/office/drawing/2014/main" id="{BB0A9D4C-14CE-4EBE-8CC7-74745E10250A}"/>
+                <a16:creationId xmlns:a16="http://schemas.microsoft.com/office/drawing/2014/main" id="{7773AD93-5E91-437C-929C-AE201315EA1E}"/>
               </a:ext>
             </a:extLst>
           </p:cNvPr>
@@ -2467,7 +2680,7 @@
           <p:cNvPr id="2" name="Left column">
             <a:extLst xmlns:a="http://schemas.openxmlformats.org/drawingml/2006/main">
               <a:ext uri="{FF2B5EF4-FFF2-40B4-BE49-F238E27FC236}">
-                <a16:creationId xmlns:a16="http://schemas.microsoft.com/office/drawing/2014/main" id="{F36E581D-CB72-424E-BBC4-0E32134104BA}"/>
+                <a16:creationId xmlns:a16="http://schemas.microsoft.com/office/drawing/2014/main" id="{E407C40F-A516-4D11-9A00-5764208F55C4}"/>
               </a:ext>
             </a:extLst>
           </p:cNvPr>
@@ -2662,12 +2875,12 @@
   </p:cSld>
   <p:clrMap bg1="lt1" tx1="dk1" bg2="lt2" tx2="dk2" accent1="accent1" accent2="accent2" accent3="accent3" accent4="accent4" accent5="accent5" accent6="accent6" hlink="hlink" folHlink="folHlink"/>
   <p:sldLayoutIdLst>
-    <p:sldLayoutId xmlns:r="http://schemas.openxmlformats.org/officeDocument/2006/relationships" id="2147483649" r:id="R4309b19059054ffa"/>
-    <p:sldLayoutId xmlns:r="http://schemas.openxmlformats.org/officeDocument/2006/relationships" id="2147483650" r:id="R9cc6471d9ee84658"/>
-    <p:sldLayoutId xmlns:r="http://schemas.openxmlformats.org/officeDocument/2006/relationships" id="2147483651" r:id="R1910d3c91e454fa5"/>
-    <p:sldLayoutId xmlns:r="http://schemas.openxmlformats.org/officeDocument/2006/relationships" id="2147483652" r:id="R30ae00277fca4c40"/>
-    <p:sldLayoutId xmlns:r="http://schemas.openxmlformats.org/officeDocument/2006/relationships" id="2147483653" r:id="R6d47c11ba58745f8"/>
-    <p:sldLayoutId xmlns:r="http://schemas.openxmlformats.org/officeDocument/2006/relationships" id="2147483654" r:id="Rc3e2c0babb954327"/>
+    <p:sldLayoutId xmlns:r="http://schemas.openxmlformats.org/officeDocument/2006/relationships" id="2147483649" r:id="R01b34c4e7cab4a57"/>
+    <p:sldLayoutId xmlns:r="http://schemas.openxmlformats.org/officeDocument/2006/relationships" id="2147483650" r:id="R37e183df951249da"/>
+    <p:sldLayoutId xmlns:r="http://schemas.openxmlformats.org/officeDocument/2006/relationships" id="2147483651" r:id="R4ed56278299a403a"/>
+    <p:sldLayoutId xmlns:r="http://schemas.openxmlformats.org/officeDocument/2006/relationships" id="2147483652" r:id="Rcc37f04280a54d09"/>
+    <p:sldLayoutId xmlns:r="http://schemas.openxmlformats.org/officeDocument/2006/relationships" id="2147483653" r:id="R08dbcfa36f934fd1"/>
+    <p:sldLayoutId xmlns:r="http://schemas.openxmlformats.org/officeDocument/2006/relationships" id="2147483654" r:id="Rc2a49169829c4b4e"/>
   </p:sldLayoutIdLst>
   <p:txStyles>
     <p:titleStyle>
@@ -3395,7 +3608,7 @@
           <p:cNvPr id="6" name="">
             <a:extLst xmlns:a="http://schemas.openxmlformats.org/drawingml/2006/main">
               <a:ext uri="{FF2B5EF4-FFF2-40B4-BE49-F238E27FC236}">
-                <a16:creationId xmlns:a16="http://schemas.microsoft.com/office/drawing/2014/main" id="{C4B0932D-216E-4B8D-BB4D-F65254CFAC4B}"/>
+                <a16:creationId xmlns:a16="http://schemas.microsoft.com/office/drawing/2014/main" id="{C28C0B85-A95E-4E7A-96C9-4C8E128CA497}"/>
               </a:ext>
             </a:extLst>
           </p:cNvPr>
@@ -3463,7 +3676,7 @@
           <p:cNvPr id="2" name="">
             <a:extLst xmlns:a="http://schemas.openxmlformats.org/drawingml/2006/main">
               <a:ext uri="{FF2B5EF4-FFF2-40B4-BE49-F238E27FC236}">
-                <a16:creationId xmlns:a16="http://schemas.microsoft.com/office/drawing/2014/main" id="{F8A78140-82F5-40E8-882C-AEE48BEA7A2F}"/>
+                <a16:creationId xmlns:a16="http://schemas.microsoft.com/office/drawing/2014/main" id="{7313677C-676E-4F58-9EE4-747C23E46725}"/>
               </a:ext>
             </a:extLst>
           </p:cNvPr>
@@ -3531,7 +3744,7 @@
           <p:cNvPr id="3" name="">
             <a:extLst xmlns:a="http://schemas.openxmlformats.org/drawingml/2006/main">
               <a:ext uri="{FF2B5EF4-FFF2-40B4-BE49-F238E27FC236}">
-                <a16:creationId xmlns:a16="http://schemas.microsoft.com/office/drawing/2014/main" id="{80F8583E-3FB5-4321-A566-794651DFAFD8}"/>
+                <a16:creationId xmlns:a16="http://schemas.microsoft.com/office/drawing/2014/main" id="{97DE63D9-08CC-4338-A455-CA1F92AEDF60}"/>
               </a:ext>
             </a:extLst>
           </p:cNvPr>
@@ -3599,7 +3812,7 @@
           <p:cNvPr id="4" name="">
             <a:extLst xmlns:a="http://schemas.openxmlformats.org/drawingml/2006/main">
               <a:ext uri="{FF2B5EF4-FFF2-40B4-BE49-F238E27FC236}">
-                <a16:creationId xmlns:a16="http://schemas.microsoft.com/office/drawing/2014/main" id="{E7D1EB3B-5DE7-415F-82F1-026D74CA16A1}"/>
+                <a16:creationId xmlns:a16="http://schemas.microsoft.com/office/drawing/2014/main" id="{FB32E962-F103-46DE-87B8-122415A3D69B}"/>
               </a:ext>
             </a:extLst>
           </p:cNvPr>
@@ -3690,7 +3903,7 @@
           <p:cNvPr id="5" name="">
             <a:extLst xmlns:a="http://schemas.openxmlformats.org/drawingml/2006/main">
               <a:ext uri="{FF2B5EF4-FFF2-40B4-BE49-F238E27FC236}">
-                <a16:creationId xmlns:a16="http://schemas.microsoft.com/office/drawing/2014/main" id="{4B9BF007-8371-4AF5-B754-4A9E23BF65E3}"/>
+                <a16:creationId xmlns:a16="http://schemas.microsoft.com/office/drawing/2014/main" id="{08B2862C-4EC6-484D-BD9A-EF6FEDCD0BDC}"/>
               </a:ext>
             </a:extLst>
           </p:cNvPr>
@@ -3756,7 +3969,1221 @@
     </p:spTree>
     <p:extLst>
       <p:ext uri="{BB962C8B-B14F-4D97-AF65-F5344CB8AC3E}">
-        <p14:creationId xmlns:p14="http://schemas.microsoft.com/office/powerpoint/2010/main" val="1614803061"/>
+        <p14:creationId xmlns:p14="http://schemas.microsoft.com/office/powerpoint/2010/main" val="1436430443"/>
+      </p:ext>
+    </p:extLst>
+  </p:cSld>
+</p:sld>
+</file>
+
+<file path=ppt/slides/slide10.xml><?xml version="1.0" encoding="utf-8"?>
+<p:sld xmlns:p="http://schemas.openxmlformats.org/presentationml/2006/main">
+  <p:cSld>
+    <p:bg>
+      <p:bgPr>
+        <a:solidFill xmlns:a="http://schemas.openxmlformats.org/drawingml/2006/main">
+          <a:srgbClr val="11181C"/>
+        </a:solidFill>
+      </p:bgPr>
+    </p:bg>
+    <p:spTree>
+      <p:nvGrpSpPr>
+        <p:cNvPr id="1" name=""/>
+        <p:cNvGrpSpPr/>
+        <p:nvPr/>
+      </p:nvGrpSpPr>
+      <p:grpSpPr>
+        <a:xfrm xmlns:a="http://schemas.openxmlformats.org/drawingml/2006/main"/>
+      </p:grpSpPr>
+      <p:sp>
+        <p:nvSpPr>
+          <p:cNvPr id="8" name="">
+            <a:extLst xmlns:a="http://schemas.openxmlformats.org/drawingml/2006/main">
+              <a:ext uri="{FF2B5EF4-FFF2-40B4-BE49-F238E27FC236}">
+                <a16:creationId xmlns:a16="http://schemas.microsoft.com/office/drawing/2014/main" id="{D4F9E693-AD49-4B60-9C86-E00642E5E7DD}"/>
+              </a:ext>
+            </a:extLst>
+          </p:cNvPr>
+          <p:cNvSpPr>
+            <a:spLocks xmlns:a="http://schemas.openxmlformats.org/drawingml/2006/main" noGrp="1"/>
+          </p:cNvSpPr>
+          <p:nvPr/>
+        </p:nvSpPr>
+        <p:spPr>
+          <a:xfrm xmlns:a="http://schemas.openxmlformats.org/drawingml/2006/main">
+            <a:off x="666750" y="457200"/>
+            <a:ext cx="10820400" cy="857250"/>
+          </a:xfrm>
+          <a:prstGeom xmlns:a="http://schemas.openxmlformats.org/drawingml/2006/main" prst="rect">
+            <a:avLst/>
+          </a:prstGeom>
+          <a:noFill xmlns:a="http://schemas.openxmlformats.org/drawingml/2006/main"/>
+          <a:ln xmlns:a="http://schemas.openxmlformats.org/drawingml/2006/main" w="0">
+            <a:noFill/>
+          </a:ln>
+        </p:spPr>
+        <p:txBody>
+          <a:bodyPr xmlns:a="http://schemas.openxmlformats.org/drawingml/2006/main">
+            <a:noAutofit/>
+          </a:bodyPr>
+          <a:lstStyle xmlns:a="http://schemas.openxmlformats.org/drawingml/2006/main">
+            <a:defPPr>
+              <a:defRPr sz="3300" b="1">
+                <a:solidFill>
+                  <a:srgbClr val="F1F5F7"/>
+                </a:solidFill>
+                <a:latin typeface="Arial"/>
+                <a:ea typeface="Arial"/>
+                <a:cs typeface="Arial"/>
+              </a:defRPr>
+            </a:defPPr>
+          </a:lstStyle>
+          <a:p xmlns:a="http://schemas.openxmlformats.org/drawingml/2006/main">
+            <a:pPr>
+              <a:defRPr sz="3300" b="1">
+                <a:solidFill>
+                  <a:srgbClr val="F1F5F7"/>
+                </a:solidFill>
+                <a:latin typeface="Arial"/>
+                <a:ea typeface="Arial"/>
+                <a:cs typeface="Arial"/>
+              </a:defRPr>
+            </a:pPr>
+            <a:r>
+              <a:rPr sz="3300" b="1">
+                <a:solidFill>
+                  <a:srgbClr val="F1F5F7"/>
+                </a:solidFill>
+                <a:latin typeface="Arial"/>
+                <a:ea typeface="Arial"/>
+                <a:cs typeface="Arial"/>
+              </a:rPr>
+              <a:t>Стек и хранение</a:t>
+            </a:r>
+          </a:p>
+        </p:txBody>
+      </p:sp>
+      <p:sp>
+        <p:nvSpPr>
+          <p:cNvPr id="2" name="">
+            <a:extLst xmlns:a="http://schemas.openxmlformats.org/drawingml/2006/main">
+              <a:ext uri="{FF2B5EF4-FFF2-40B4-BE49-F238E27FC236}">
+                <a16:creationId xmlns:a16="http://schemas.microsoft.com/office/drawing/2014/main" id="{1C4D8F38-A13F-409D-8455-35E86A7B8662}"/>
+              </a:ext>
+            </a:extLst>
+          </p:cNvPr>
+          <p:cNvSpPr>
+            <a:spLocks xmlns:a="http://schemas.openxmlformats.org/drawingml/2006/main" noGrp="1"/>
+          </p:cNvSpPr>
+          <p:nvPr/>
+        </p:nvSpPr>
+        <p:spPr>
+          <a:xfrm xmlns:a="http://schemas.openxmlformats.org/drawingml/2006/main">
+            <a:off x="685800" y="1609725"/>
+            <a:ext cx="10382250" cy="619125"/>
+          </a:xfrm>
+          <a:prstGeom xmlns:a="http://schemas.openxmlformats.org/drawingml/2006/main" prst="rect">
+            <a:avLst/>
+          </a:prstGeom>
+          <a:noFill xmlns:a="http://schemas.openxmlformats.org/drawingml/2006/main"/>
+          <a:ln xmlns:a="http://schemas.openxmlformats.org/drawingml/2006/main" w="0">
+            <a:noFill/>
+          </a:ln>
+        </p:spPr>
+        <p:txBody>
+          <a:bodyPr xmlns:a="http://schemas.openxmlformats.org/drawingml/2006/main">
+            <a:noAutofit/>
+          </a:bodyPr>
+          <a:lstStyle xmlns:a="http://schemas.openxmlformats.org/drawingml/2006/main">
+            <a:defPPr>
+              <a:defRPr sz="3225" b="1">
+                <a:solidFill>
+                  <a:srgbClr val="7496FF"/>
+                </a:solidFill>
+                <a:latin typeface="Arial"/>
+                <a:ea typeface="Arial"/>
+                <a:cs typeface="Arial"/>
+              </a:defRPr>
+            </a:defPPr>
+          </a:lstStyle>
+          <a:p xmlns:a="http://schemas.openxmlformats.org/drawingml/2006/main">
+            <a:pPr>
+              <a:defRPr sz="3225" b="1">
+                <a:solidFill>
+                  <a:srgbClr val="7496FF"/>
+                </a:solidFill>
+                <a:latin typeface="Arial"/>
+                <a:ea typeface="Arial"/>
+                <a:cs typeface="Arial"/>
+              </a:defRPr>
+            </a:pPr>
+            <a:r>
+              <a:rPr sz="3225" b="1">
+                <a:solidFill>
+                  <a:srgbClr val="7496FF"/>
+                </a:solidFill>
+                <a:latin typeface="Arial"/>
+                <a:ea typeface="Arial"/>
+                <a:cs typeface="Arial"/>
+              </a:rPr>
+              <a:t>React + TypeScript</a:t>
+            </a:r>
+          </a:p>
+        </p:txBody>
+      </p:sp>
+      <p:sp>
+        <p:nvSpPr>
+          <p:cNvPr id="3" name="">
+            <a:extLst xmlns:a="http://schemas.openxmlformats.org/drawingml/2006/main">
+              <a:ext uri="{FF2B5EF4-FFF2-40B4-BE49-F238E27FC236}">
+                <a16:creationId xmlns:a16="http://schemas.microsoft.com/office/drawing/2014/main" id="{4F595DE0-9EEB-4784-9981-65FFCC2A014A}"/>
+              </a:ext>
+            </a:extLst>
+          </p:cNvPr>
+          <p:cNvSpPr>
+            <a:spLocks xmlns:a="http://schemas.openxmlformats.org/drawingml/2006/main" noGrp="1"/>
+          </p:cNvSpPr>
+          <p:nvPr/>
+        </p:nvSpPr>
+        <p:spPr>
+          <a:xfrm xmlns:a="http://schemas.openxmlformats.org/drawingml/2006/main">
+            <a:off x="685800" y="2333625"/>
+            <a:ext cx="10382250" cy="476250"/>
+          </a:xfrm>
+          <a:prstGeom xmlns:a="http://schemas.openxmlformats.org/drawingml/2006/main" prst="rect">
+            <a:avLst/>
+          </a:prstGeom>
+          <a:noFill xmlns:a="http://schemas.openxmlformats.org/drawingml/2006/main"/>
+          <a:ln xmlns:a="http://schemas.openxmlformats.org/drawingml/2006/main" w="0">
+            <a:noFill/>
+          </a:ln>
+        </p:spPr>
+        <p:txBody>
+          <a:bodyPr xmlns:a="http://schemas.openxmlformats.org/drawingml/2006/main">
+            <a:noAutofit/>
+          </a:bodyPr>
+          <a:lstStyle xmlns:a="http://schemas.openxmlformats.org/drawingml/2006/main">
+            <a:defPPr>
+              <a:defRPr sz="2175" b="0">
+                <a:solidFill>
+                  <a:srgbClr val="B0BDC5"/>
+                </a:solidFill>
+                <a:latin typeface="Arial"/>
+                <a:ea typeface="Arial"/>
+                <a:cs typeface="Arial"/>
+              </a:defRPr>
+            </a:defPPr>
+          </a:lstStyle>
+          <a:p xmlns:a="http://schemas.openxmlformats.org/drawingml/2006/main">
+            <a:pPr>
+              <a:defRPr sz="2175" b="0">
+                <a:solidFill>
+                  <a:srgbClr val="B0BDC5"/>
+                </a:solidFill>
+                <a:latin typeface="Arial"/>
+                <a:ea typeface="Arial"/>
+                <a:cs typeface="Arial"/>
+              </a:defRPr>
+            </a:pPr>
+            <a:r>
+              <a:rPr sz="2175" b="0">
+                <a:solidFill>
+                  <a:srgbClr val="B0BDC5"/>
+                </a:solidFill>
+                <a:latin typeface="Arial"/>
+                <a:ea typeface="Arial"/>
+                <a:cs typeface="Arial"/>
+              </a:rPr>
+              <a:t>Vite, Tailwind, TanStack Query</a:t>
+            </a:r>
+          </a:p>
+        </p:txBody>
+      </p:sp>
+      <p:sp>
+        <p:nvSpPr>
+          <p:cNvPr id="4" name="">
+            <a:extLst xmlns:a="http://schemas.openxmlformats.org/drawingml/2006/main">
+              <a:ext uri="{FF2B5EF4-FFF2-40B4-BE49-F238E27FC236}">
+                <a16:creationId xmlns:a16="http://schemas.microsoft.com/office/drawing/2014/main" id="{FFAE8202-5F91-4F97-9935-3F32FF700639}"/>
+              </a:ext>
+            </a:extLst>
+          </p:cNvPr>
+          <p:cNvSpPr>
+            <a:spLocks xmlns:a="http://schemas.openxmlformats.org/drawingml/2006/main" noGrp="1"/>
+          </p:cNvSpPr>
+          <p:nvPr/>
+        </p:nvSpPr>
+        <p:spPr>
+          <a:xfrm xmlns:a="http://schemas.openxmlformats.org/drawingml/2006/main">
+            <a:off x="685800" y="3238500"/>
+            <a:ext cx="10382250" cy="619125"/>
+          </a:xfrm>
+          <a:prstGeom xmlns:a="http://schemas.openxmlformats.org/drawingml/2006/main" prst="rect">
+            <a:avLst/>
+          </a:prstGeom>
+          <a:noFill xmlns:a="http://schemas.openxmlformats.org/drawingml/2006/main"/>
+          <a:ln xmlns:a="http://schemas.openxmlformats.org/drawingml/2006/main" w="0">
+            <a:noFill/>
+          </a:ln>
+        </p:spPr>
+        <p:txBody>
+          <a:bodyPr xmlns:a="http://schemas.openxmlformats.org/drawingml/2006/main">
+            <a:noAutofit/>
+          </a:bodyPr>
+          <a:lstStyle xmlns:a="http://schemas.openxmlformats.org/drawingml/2006/main">
+            <a:defPPr>
+              <a:defRPr sz="3225" b="1">
+                <a:solidFill>
+                  <a:srgbClr val="F1F5F7"/>
+                </a:solidFill>
+                <a:latin typeface="Arial"/>
+                <a:ea typeface="Arial"/>
+                <a:cs typeface="Arial"/>
+              </a:defRPr>
+            </a:defPPr>
+          </a:lstStyle>
+          <a:p xmlns:a="http://schemas.openxmlformats.org/drawingml/2006/main">
+            <a:pPr>
+              <a:defRPr sz="3225" b="1">
+                <a:solidFill>
+                  <a:srgbClr val="F1F5F7"/>
+                </a:solidFill>
+                <a:latin typeface="Arial"/>
+                <a:ea typeface="Arial"/>
+                <a:cs typeface="Arial"/>
+              </a:defRPr>
+            </a:pPr>
+            <a:r>
+              <a:rPr sz="3225" b="1">
+                <a:solidFill>
+                  <a:srgbClr val="F1F5F7"/>
+                </a:solidFill>
+                <a:latin typeface="Arial"/>
+                <a:ea typeface="Arial"/>
+                <a:cs typeface="Arial"/>
+              </a:rPr>
+              <a:t>Go + chi + Huma</a:t>
+            </a:r>
+          </a:p>
+        </p:txBody>
+      </p:sp>
+      <p:sp>
+        <p:nvSpPr>
+          <p:cNvPr id="5" name="">
+            <a:extLst xmlns:a="http://schemas.openxmlformats.org/drawingml/2006/main">
+              <a:ext uri="{FF2B5EF4-FFF2-40B4-BE49-F238E27FC236}">
+                <a16:creationId xmlns:a16="http://schemas.microsoft.com/office/drawing/2014/main" id="{78EA23F1-FA01-48D9-8F25-549A60AC2231}"/>
+              </a:ext>
+            </a:extLst>
+          </p:cNvPr>
+          <p:cNvSpPr>
+            <a:spLocks xmlns:a="http://schemas.openxmlformats.org/drawingml/2006/main" noGrp="1"/>
+          </p:cNvSpPr>
+          <p:nvPr/>
+        </p:nvSpPr>
+        <p:spPr>
+          <a:xfrm xmlns:a="http://schemas.openxmlformats.org/drawingml/2006/main">
+            <a:off x="685800" y="3971925"/>
+            <a:ext cx="10382250" cy="476250"/>
+          </a:xfrm>
+          <a:prstGeom xmlns:a="http://schemas.openxmlformats.org/drawingml/2006/main" prst="rect">
+            <a:avLst/>
+          </a:prstGeom>
+          <a:noFill xmlns:a="http://schemas.openxmlformats.org/drawingml/2006/main"/>
+          <a:ln xmlns:a="http://schemas.openxmlformats.org/drawingml/2006/main" w="0">
+            <a:noFill/>
+          </a:ln>
+        </p:spPr>
+        <p:txBody>
+          <a:bodyPr xmlns:a="http://schemas.openxmlformats.org/drawingml/2006/main">
+            <a:noAutofit/>
+          </a:bodyPr>
+          <a:lstStyle xmlns:a="http://schemas.openxmlformats.org/drawingml/2006/main">
+            <a:defPPr>
+              <a:defRPr sz="2175" b="0">
+                <a:solidFill>
+                  <a:srgbClr val="B0BDC5"/>
+                </a:solidFill>
+                <a:latin typeface="Arial"/>
+                <a:ea typeface="Arial"/>
+                <a:cs typeface="Arial"/>
+              </a:defRPr>
+            </a:defPPr>
+          </a:lstStyle>
+          <a:p xmlns:a="http://schemas.openxmlformats.org/drawingml/2006/main">
+            <a:pPr>
+              <a:defRPr sz="2175" b="0">
+                <a:solidFill>
+                  <a:srgbClr val="B0BDC5"/>
+                </a:solidFill>
+                <a:latin typeface="Arial"/>
+                <a:ea typeface="Arial"/>
+                <a:cs typeface="Arial"/>
+              </a:defRPr>
+            </a:pPr>
+            <a:r>
+              <a:rPr sz="2175" b="0">
+                <a:solidFill>
+                  <a:srgbClr val="B0BDC5"/>
+                </a:solidFill>
+                <a:latin typeface="Arial"/>
+                <a:ea typeface="Arial"/>
+                <a:cs typeface="Arial"/>
+              </a:rPr>
+              <a:t>Модульный монолит, OpenAPI, SMTP outbox</a:t>
+            </a:r>
+          </a:p>
+        </p:txBody>
+      </p:sp>
+      <p:sp>
+        <p:nvSpPr>
+          <p:cNvPr id="6" name="">
+            <a:extLst xmlns:a="http://schemas.openxmlformats.org/drawingml/2006/main">
+              <a:ext uri="{FF2B5EF4-FFF2-40B4-BE49-F238E27FC236}">
+                <a16:creationId xmlns:a16="http://schemas.microsoft.com/office/drawing/2014/main" id="{86A6288E-9C1A-40D9-8DF6-4EEF84E922F9}"/>
+              </a:ext>
+            </a:extLst>
+          </p:cNvPr>
+          <p:cNvSpPr>
+            <a:spLocks xmlns:a="http://schemas.openxmlformats.org/drawingml/2006/main" noGrp="1"/>
+          </p:cNvSpPr>
+          <p:nvPr/>
+        </p:nvSpPr>
+        <p:spPr>
+          <a:xfrm xmlns:a="http://schemas.openxmlformats.org/drawingml/2006/main">
+            <a:off x="685800" y="4819650"/>
+            <a:ext cx="10382250" cy="619125"/>
+          </a:xfrm>
+          <a:prstGeom xmlns:a="http://schemas.openxmlformats.org/drawingml/2006/main" prst="rect">
+            <a:avLst/>
+          </a:prstGeom>
+          <a:noFill xmlns:a="http://schemas.openxmlformats.org/drawingml/2006/main"/>
+          <a:ln xmlns:a="http://schemas.openxmlformats.org/drawingml/2006/main" w="0">
+            <a:noFill/>
+          </a:ln>
+        </p:spPr>
+        <p:txBody>
+          <a:bodyPr xmlns:a="http://schemas.openxmlformats.org/drawingml/2006/main">
+            <a:noAutofit/>
+          </a:bodyPr>
+          <a:lstStyle xmlns:a="http://schemas.openxmlformats.org/drawingml/2006/main">
+            <a:defPPr>
+              <a:defRPr sz="3225" b="1">
+                <a:solidFill>
+                  <a:srgbClr val="F1F5F7"/>
+                </a:solidFill>
+                <a:latin typeface="Arial"/>
+                <a:ea typeface="Arial"/>
+                <a:cs typeface="Arial"/>
+              </a:defRPr>
+            </a:defPPr>
+          </a:lstStyle>
+          <a:p xmlns:a="http://schemas.openxmlformats.org/drawingml/2006/main">
+            <a:pPr>
+              <a:defRPr sz="3225" b="1">
+                <a:solidFill>
+                  <a:srgbClr val="F1F5F7"/>
+                </a:solidFill>
+                <a:latin typeface="Arial"/>
+                <a:ea typeface="Arial"/>
+                <a:cs typeface="Arial"/>
+              </a:defRPr>
+            </a:pPr>
+            <a:r>
+              <a:rPr sz="3225" b="1">
+                <a:solidFill>
+                  <a:srgbClr val="F1F5F7"/>
+                </a:solidFill>
+                <a:latin typeface="Arial"/>
+                <a:ea typeface="Arial"/>
+                <a:cs typeface="Arial"/>
+              </a:rPr>
+              <a:t>PostgreSQL + Redis</a:t>
+            </a:r>
+          </a:p>
+        </p:txBody>
+      </p:sp>
+      <p:sp>
+        <p:nvSpPr>
+          <p:cNvPr id="7" name="">
+            <a:extLst xmlns:a="http://schemas.openxmlformats.org/drawingml/2006/main">
+              <a:ext uri="{FF2B5EF4-FFF2-40B4-BE49-F238E27FC236}">
+                <a16:creationId xmlns:a16="http://schemas.microsoft.com/office/drawing/2014/main" id="{6712598D-A400-4939-A94A-8C11AB39746B}"/>
+              </a:ext>
+            </a:extLst>
+          </p:cNvPr>
+          <p:cNvSpPr>
+            <a:spLocks xmlns:a="http://schemas.openxmlformats.org/drawingml/2006/main" noGrp="1"/>
+          </p:cNvSpPr>
+          <p:nvPr/>
+        </p:nvSpPr>
+        <p:spPr>
+          <a:xfrm xmlns:a="http://schemas.openxmlformats.org/drawingml/2006/main">
+            <a:off x="685800" y="5553075"/>
+            <a:ext cx="10382250" cy="523875"/>
+          </a:xfrm>
+          <a:prstGeom xmlns:a="http://schemas.openxmlformats.org/drawingml/2006/main" prst="rect">
+            <a:avLst/>
+          </a:prstGeom>
+          <a:noFill xmlns:a="http://schemas.openxmlformats.org/drawingml/2006/main"/>
+          <a:ln xmlns:a="http://schemas.openxmlformats.org/drawingml/2006/main" w="0">
+            <a:noFill/>
+          </a:ln>
+        </p:spPr>
+        <p:txBody>
+          <a:bodyPr xmlns:a="http://schemas.openxmlformats.org/drawingml/2006/main">
+            <a:noAutofit/>
+          </a:bodyPr>
+          <a:lstStyle xmlns:a="http://schemas.openxmlformats.org/drawingml/2006/main">
+            <a:defPPr>
+              <a:defRPr sz="2175" b="0">
+                <a:solidFill>
+                  <a:srgbClr val="B0BDC5"/>
+                </a:solidFill>
+                <a:latin typeface="Arial"/>
+                <a:ea typeface="Arial"/>
+                <a:cs typeface="Arial"/>
+              </a:defRPr>
+            </a:defPPr>
+          </a:lstStyle>
+          <a:p xmlns:a="http://schemas.openxmlformats.org/drawingml/2006/main">
+            <a:pPr>
+              <a:defRPr sz="2175" b="0">
+                <a:solidFill>
+                  <a:srgbClr val="B0BDC5"/>
+                </a:solidFill>
+                <a:latin typeface="Arial"/>
+                <a:ea typeface="Arial"/>
+                <a:cs typeface="Arial"/>
+              </a:defRPr>
+            </a:pPr>
+            <a:r>
+              <a:rPr sz="2175" b="0">
+                <a:solidFill>
+                  <a:srgbClr val="B0BDC5"/>
+                </a:solidFill>
+                <a:latin typeface="Arial"/>
+                <a:ea typeface="Arial"/>
+                <a:cs typeface="Arial"/>
+              </a:rPr>
+              <a:t>Результаты и правила в БД. Сессии и лимиты в Redis.</a:t>
+            </a:r>
+          </a:p>
+        </p:txBody>
+      </p:sp>
+    </p:spTree>
+    <p:extLst>
+      <p:ext uri="{BB962C8B-B14F-4D97-AF65-F5344CB8AC3E}">
+        <p14:creationId xmlns:p14="http://schemas.microsoft.com/office/powerpoint/2010/main" val="801394994"/>
+      </p:ext>
+    </p:extLst>
+  </p:cSld>
+</p:sld>
+</file>
+
+<file path=ppt/slides/slide11.xml><?xml version="1.0" encoding="utf-8"?>
+<p:sld xmlns:p="http://schemas.openxmlformats.org/presentationml/2006/main">
+  <p:cSld>
+    <p:bg>
+      <p:bgPr>
+        <a:solidFill xmlns:a="http://schemas.openxmlformats.org/drawingml/2006/main">
+          <a:srgbClr val="11181C"/>
+        </a:solidFill>
+      </p:bgPr>
+    </p:bg>
+    <p:spTree>
+      <p:nvGrpSpPr>
+        <p:cNvPr id="1" name=""/>
+        <p:cNvGrpSpPr/>
+        <p:nvPr/>
+      </p:nvGrpSpPr>
+      <p:grpSpPr>
+        <a:xfrm xmlns:a="http://schemas.openxmlformats.org/drawingml/2006/main"/>
+      </p:grpSpPr>
+      <p:sp>
+        <p:nvSpPr>
+          <p:cNvPr id="11" name="">
+            <a:extLst xmlns:a="http://schemas.openxmlformats.org/drawingml/2006/main">
+              <a:ext uri="{FF2B5EF4-FFF2-40B4-BE49-F238E27FC236}">
+                <a16:creationId xmlns:a16="http://schemas.microsoft.com/office/drawing/2014/main" id="{4A65AE7F-DC3F-424B-B01A-23C2E46BE487}"/>
+              </a:ext>
+            </a:extLst>
+          </p:cNvPr>
+          <p:cNvSpPr>
+            <a:spLocks xmlns:a="http://schemas.openxmlformats.org/drawingml/2006/main" noGrp="1"/>
+          </p:cNvSpPr>
+          <p:nvPr/>
+        </p:nvSpPr>
+        <p:spPr>
+          <a:xfrm xmlns:a="http://schemas.openxmlformats.org/drawingml/2006/main">
+            <a:off x="666750" y="457200"/>
+            <a:ext cx="10820400" cy="857250"/>
+          </a:xfrm>
+          <a:prstGeom xmlns:a="http://schemas.openxmlformats.org/drawingml/2006/main" prst="rect">
+            <a:avLst/>
+          </a:prstGeom>
+          <a:noFill xmlns:a="http://schemas.openxmlformats.org/drawingml/2006/main"/>
+          <a:ln xmlns:a="http://schemas.openxmlformats.org/drawingml/2006/main" w="0">
+            <a:noFill/>
+          </a:ln>
+        </p:spPr>
+        <p:txBody>
+          <a:bodyPr xmlns:a="http://schemas.openxmlformats.org/drawingml/2006/main">
+            <a:noAutofit/>
+          </a:bodyPr>
+          <a:lstStyle xmlns:a="http://schemas.openxmlformats.org/drawingml/2006/main">
+            <a:defPPr>
+              <a:defRPr sz="3300" b="1">
+                <a:solidFill>
+                  <a:srgbClr val="F1F5F7"/>
+                </a:solidFill>
+                <a:latin typeface="Arial"/>
+                <a:ea typeface="Arial"/>
+                <a:cs typeface="Arial"/>
+              </a:defRPr>
+            </a:defPPr>
+          </a:lstStyle>
+          <a:p xmlns:a="http://schemas.openxmlformats.org/drawingml/2006/main">
+            <a:pPr>
+              <a:defRPr sz="3300" b="1">
+                <a:solidFill>
+                  <a:srgbClr val="F1F5F7"/>
+                </a:solidFill>
+                <a:latin typeface="Arial"/>
+                <a:ea typeface="Arial"/>
+                <a:cs typeface="Arial"/>
+              </a:defRPr>
+            </a:pPr>
+            <a:r>
+              <a:rPr sz="3300" b="1">
+                <a:solidFill>
+                  <a:srgbClr val="F1F5F7"/>
+                </a:solidFill>
+                <a:latin typeface="Arial"/>
+                <a:ea typeface="Arial"/>
+                <a:cs typeface="Arial"/>
+              </a:rPr>
+              <a:t>Следующий этап</a:t>
+            </a:r>
+          </a:p>
+        </p:txBody>
+      </p:sp>
+      <p:sp>
+        <p:nvSpPr>
+          <p:cNvPr id="2" name="">
+            <a:extLst xmlns:a="http://schemas.openxmlformats.org/drawingml/2006/main">
+              <a:ext uri="{FF2B5EF4-FFF2-40B4-BE49-F238E27FC236}">
+                <a16:creationId xmlns:a16="http://schemas.microsoft.com/office/drawing/2014/main" id="{CBC178E0-8269-47B3-A3F9-9E6C0CF5EA3E}"/>
+              </a:ext>
+            </a:extLst>
+          </p:cNvPr>
+          <p:cNvSpPr>
+            <a:spLocks xmlns:a="http://schemas.openxmlformats.org/drawingml/2006/main" noGrp="1"/>
+          </p:cNvSpPr>
+          <p:nvPr/>
+        </p:nvSpPr>
+        <p:spPr>
+          <a:xfrm xmlns:a="http://schemas.openxmlformats.org/drawingml/2006/main">
+            <a:off x="685800" y="1504950"/>
+            <a:ext cx="742950" cy="647700"/>
+          </a:xfrm>
+          <a:prstGeom xmlns:a="http://schemas.openxmlformats.org/drawingml/2006/main" prst="rect">
+            <a:avLst/>
+          </a:prstGeom>
+          <a:noFill xmlns:a="http://schemas.openxmlformats.org/drawingml/2006/main"/>
+          <a:ln xmlns:a="http://schemas.openxmlformats.org/drawingml/2006/main" w="0">
+            <a:noFill/>
+          </a:ln>
+        </p:spPr>
+        <p:txBody>
+          <a:bodyPr xmlns:a="http://schemas.openxmlformats.org/drawingml/2006/main">
+            <a:noAutofit/>
+          </a:bodyPr>
+          <a:lstStyle xmlns:a="http://schemas.openxmlformats.org/drawingml/2006/main">
+            <a:defPPr>
+              <a:defRPr sz="3150" b="1">
+                <a:solidFill>
+                  <a:srgbClr val="7496FF"/>
+                </a:solidFill>
+                <a:latin typeface="Arial"/>
+                <a:ea typeface="Arial"/>
+                <a:cs typeface="Arial"/>
+              </a:defRPr>
+            </a:defPPr>
+          </a:lstStyle>
+          <a:p xmlns:a="http://schemas.openxmlformats.org/drawingml/2006/main">
+            <a:pPr>
+              <a:defRPr sz="3150" b="1">
+                <a:solidFill>
+                  <a:srgbClr val="7496FF"/>
+                </a:solidFill>
+                <a:latin typeface="Arial"/>
+                <a:ea typeface="Arial"/>
+                <a:cs typeface="Arial"/>
+              </a:defRPr>
+            </a:pPr>
+            <a:r>
+              <a:rPr sz="3150" b="1">
+                <a:solidFill>
+                  <a:srgbClr val="7496FF"/>
+                </a:solidFill>
+                <a:latin typeface="Arial"/>
+                <a:ea typeface="Arial"/>
+                <a:cs typeface="Arial"/>
+              </a:rPr>
+              <a:t>01</a:t>
+            </a:r>
+          </a:p>
+        </p:txBody>
+      </p:sp>
+      <p:sp>
+        <p:nvSpPr>
+          <p:cNvPr id="3" name="">
+            <a:extLst xmlns:a="http://schemas.openxmlformats.org/drawingml/2006/main">
+              <a:ext uri="{FF2B5EF4-FFF2-40B4-BE49-F238E27FC236}">
+                <a16:creationId xmlns:a16="http://schemas.microsoft.com/office/drawing/2014/main" id="{606F2908-EF42-4619-8EBA-B760DE95ABAE}"/>
+              </a:ext>
+            </a:extLst>
+          </p:cNvPr>
+          <p:cNvSpPr>
+            <a:spLocks xmlns:a="http://schemas.openxmlformats.org/drawingml/2006/main" noGrp="1"/>
+          </p:cNvSpPr>
+          <p:nvPr/>
+        </p:nvSpPr>
+        <p:spPr>
+          <a:xfrm xmlns:a="http://schemas.openxmlformats.org/drawingml/2006/main">
+            <a:off x="1685925" y="1504950"/>
+            <a:ext cx="9525000" cy="457200"/>
+          </a:xfrm>
+          <a:prstGeom xmlns:a="http://schemas.openxmlformats.org/drawingml/2006/main" prst="rect">
+            <a:avLst/>
+          </a:prstGeom>
+          <a:noFill xmlns:a="http://schemas.openxmlformats.org/drawingml/2006/main"/>
+          <a:ln xmlns:a="http://schemas.openxmlformats.org/drawingml/2006/main" w="0">
+            <a:noFill/>
+          </a:ln>
+        </p:spPr>
+        <p:txBody>
+          <a:bodyPr xmlns:a="http://schemas.openxmlformats.org/drawingml/2006/main">
+            <a:noAutofit/>
+          </a:bodyPr>
+          <a:lstStyle xmlns:a="http://schemas.openxmlformats.org/drawingml/2006/main">
+            <a:defPPr>
+              <a:defRPr sz="2250" b="1">
+                <a:solidFill>
+                  <a:srgbClr val="F1F5F7"/>
+                </a:solidFill>
+                <a:latin typeface="Arial"/>
+                <a:ea typeface="Arial"/>
+                <a:cs typeface="Arial"/>
+              </a:defRPr>
+            </a:defPPr>
+          </a:lstStyle>
+          <a:p xmlns:a="http://schemas.openxmlformats.org/drawingml/2006/main">
+            <a:pPr>
+              <a:defRPr sz="2250" b="1">
+                <a:solidFill>
+                  <a:srgbClr val="F1F5F7"/>
+                </a:solidFill>
+                <a:latin typeface="Arial"/>
+                <a:ea typeface="Arial"/>
+                <a:cs typeface="Arial"/>
+              </a:defRPr>
+            </a:pPr>
+            <a:r>
+              <a:rPr sz="2250" b="1">
+                <a:solidFill>
+                  <a:srgbClr val="F1F5F7"/>
+                </a:solidFill>
+                <a:latin typeface="Arial"/>
+                <a:ea typeface="Arial"/>
+                <a:cs typeface="Arial"/>
+              </a:rPr>
+              <a:t>Экспертная калибровка</a:t>
+            </a:r>
+          </a:p>
+        </p:txBody>
+      </p:sp>
+      <p:sp>
+        <p:nvSpPr>
+          <p:cNvPr id="4" name="">
+            <a:extLst xmlns:a="http://schemas.openxmlformats.org/drawingml/2006/main">
+              <a:ext uri="{FF2B5EF4-FFF2-40B4-BE49-F238E27FC236}">
+                <a16:creationId xmlns:a16="http://schemas.microsoft.com/office/drawing/2014/main" id="{432A462F-C6B1-4AF4-A28D-ADD9B94F0B28}"/>
+              </a:ext>
+            </a:extLst>
+          </p:cNvPr>
+          <p:cNvSpPr>
+            <a:spLocks xmlns:a="http://schemas.openxmlformats.org/drawingml/2006/main" noGrp="1"/>
+          </p:cNvSpPr>
+          <p:nvPr/>
+        </p:nvSpPr>
+        <p:spPr>
+          <a:xfrm xmlns:a="http://schemas.openxmlformats.org/drawingml/2006/main">
+            <a:off x="1685925" y="2047875"/>
+            <a:ext cx="9525000" cy="781050"/>
+          </a:xfrm>
+          <a:prstGeom xmlns:a="http://schemas.openxmlformats.org/drawingml/2006/main" prst="rect">
+            <a:avLst/>
+          </a:prstGeom>
+          <a:noFill xmlns:a="http://schemas.openxmlformats.org/drawingml/2006/main"/>
+          <a:ln xmlns:a="http://schemas.openxmlformats.org/drawingml/2006/main" w="0">
+            <a:noFill/>
+          </a:ln>
+        </p:spPr>
+        <p:txBody>
+          <a:bodyPr xmlns:a="http://schemas.openxmlformats.org/drawingml/2006/main">
+            <a:noAutofit/>
+          </a:bodyPr>
+          <a:lstStyle xmlns:a="http://schemas.openxmlformats.org/drawingml/2006/main">
+            <a:defPPr>
+              <a:defRPr sz="1950" b="0">
+                <a:solidFill>
+                  <a:srgbClr val="B0BDC5"/>
+                </a:solidFill>
+                <a:latin typeface="Arial"/>
+                <a:ea typeface="Arial"/>
+                <a:cs typeface="Arial"/>
+              </a:defRPr>
+            </a:defPPr>
+          </a:lstStyle>
+          <a:p xmlns:a="http://schemas.openxmlformats.org/drawingml/2006/main">
+            <a:pPr>
+              <a:defRPr sz="1950" b="0">
+                <a:solidFill>
+                  <a:srgbClr val="B0BDC5"/>
+                </a:solidFill>
+                <a:latin typeface="Arial"/>
+                <a:ea typeface="Arial"/>
+                <a:cs typeface="Arial"/>
+              </a:defRPr>
+            </a:pPr>
+            <a:r>
+              <a:rPr sz="1950" b="0">
+                <a:solidFill>
+                  <a:srgbClr val="B0BDC5"/>
+                </a:solidFill>
+                <a:latin typeface="Arial"/>
+                <a:ea typeface="Arial"/>
+                <a:cs typeface="Arial"/>
+              </a:rPr>
+              <a:t>Расширение банка, независимая разметка грейдов и качества подбора.</a:t>
+            </a:r>
+          </a:p>
+        </p:txBody>
+      </p:sp>
+      <p:sp>
+        <p:nvSpPr>
+          <p:cNvPr id="5" name="">
+            <a:extLst xmlns:a="http://schemas.openxmlformats.org/drawingml/2006/main">
+              <a:ext uri="{FF2B5EF4-FFF2-40B4-BE49-F238E27FC236}">
+                <a16:creationId xmlns:a16="http://schemas.microsoft.com/office/drawing/2014/main" id="{322346D5-FBAF-40C8-B914-E67C76C25FB7}"/>
+              </a:ext>
+            </a:extLst>
+          </p:cNvPr>
+          <p:cNvSpPr>
+            <a:spLocks xmlns:a="http://schemas.openxmlformats.org/drawingml/2006/main" noGrp="1"/>
+          </p:cNvSpPr>
+          <p:nvPr/>
+        </p:nvSpPr>
+        <p:spPr>
+          <a:xfrm xmlns:a="http://schemas.openxmlformats.org/drawingml/2006/main">
+            <a:off x="685800" y="3057525"/>
+            <a:ext cx="742950" cy="647700"/>
+          </a:xfrm>
+          <a:prstGeom xmlns:a="http://schemas.openxmlformats.org/drawingml/2006/main" prst="rect">
+            <a:avLst/>
+          </a:prstGeom>
+          <a:noFill xmlns:a="http://schemas.openxmlformats.org/drawingml/2006/main"/>
+          <a:ln xmlns:a="http://schemas.openxmlformats.org/drawingml/2006/main" w="0">
+            <a:noFill/>
+          </a:ln>
+        </p:spPr>
+        <p:txBody>
+          <a:bodyPr xmlns:a="http://schemas.openxmlformats.org/drawingml/2006/main">
+            <a:noAutofit/>
+          </a:bodyPr>
+          <a:lstStyle xmlns:a="http://schemas.openxmlformats.org/drawingml/2006/main">
+            <a:defPPr>
+              <a:defRPr sz="3150" b="1">
+                <a:solidFill>
+                  <a:srgbClr val="7496FF"/>
+                </a:solidFill>
+                <a:latin typeface="Arial"/>
+                <a:ea typeface="Arial"/>
+                <a:cs typeface="Arial"/>
+              </a:defRPr>
+            </a:defPPr>
+          </a:lstStyle>
+          <a:p xmlns:a="http://schemas.openxmlformats.org/drawingml/2006/main">
+            <a:pPr>
+              <a:defRPr sz="3150" b="1">
+                <a:solidFill>
+                  <a:srgbClr val="7496FF"/>
+                </a:solidFill>
+                <a:latin typeface="Arial"/>
+                <a:ea typeface="Arial"/>
+                <a:cs typeface="Arial"/>
+              </a:defRPr>
+            </a:pPr>
+            <a:r>
+              <a:rPr sz="3150" b="1">
+                <a:solidFill>
+                  <a:srgbClr val="7496FF"/>
+                </a:solidFill>
+                <a:latin typeface="Arial"/>
+                <a:ea typeface="Arial"/>
+                <a:cs typeface="Arial"/>
+              </a:rPr>
+              <a:t>02</a:t>
+            </a:r>
+          </a:p>
+        </p:txBody>
+      </p:sp>
+      <p:sp>
+        <p:nvSpPr>
+          <p:cNvPr id="6" name="">
+            <a:extLst xmlns:a="http://schemas.openxmlformats.org/drawingml/2006/main">
+              <a:ext uri="{FF2B5EF4-FFF2-40B4-BE49-F238E27FC236}">
+                <a16:creationId xmlns:a16="http://schemas.microsoft.com/office/drawing/2014/main" id="{E5BED6BD-E7E9-453B-8754-8E5BDD39AD62}"/>
+              </a:ext>
+            </a:extLst>
+          </p:cNvPr>
+          <p:cNvSpPr>
+            <a:spLocks xmlns:a="http://schemas.openxmlformats.org/drawingml/2006/main" noGrp="1"/>
+          </p:cNvSpPr>
+          <p:nvPr/>
+        </p:nvSpPr>
+        <p:spPr>
+          <a:xfrm xmlns:a="http://schemas.openxmlformats.org/drawingml/2006/main">
+            <a:off x="1685925" y="3057525"/>
+            <a:ext cx="9525000" cy="457200"/>
+          </a:xfrm>
+          <a:prstGeom xmlns:a="http://schemas.openxmlformats.org/drawingml/2006/main" prst="rect">
+            <a:avLst/>
+          </a:prstGeom>
+          <a:noFill xmlns:a="http://schemas.openxmlformats.org/drawingml/2006/main"/>
+          <a:ln xmlns:a="http://schemas.openxmlformats.org/drawingml/2006/main" w="0">
+            <a:noFill/>
+          </a:ln>
+        </p:spPr>
+        <p:txBody>
+          <a:bodyPr xmlns:a="http://schemas.openxmlformats.org/drawingml/2006/main">
+            <a:noAutofit/>
+          </a:bodyPr>
+          <a:lstStyle xmlns:a="http://schemas.openxmlformats.org/drawingml/2006/main">
+            <a:defPPr>
+              <a:defRPr sz="2250" b="1">
+                <a:solidFill>
+                  <a:srgbClr val="F1F5F7"/>
+                </a:solidFill>
+                <a:latin typeface="Arial"/>
+                <a:ea typeface="Arial"/>
+                <a:cs typeface="Arial"/>
+              </a:defRPr>
+            </a:defPPr>
+          </a:lstStyle>
+          <a:p xmlns:a="http://schemas.openxmlformats.org/drawingml/2006/main">
+            <a:pPr>
+              <a:defRPr sz="2250" b="1">
+                <a:solidFill>
+                  <a:srgbClr val="F1F5F7"/>
+                </a:solidFill>
+                <a:latin typeface="Arial"/>
+                <a:ea typeface="Arial"/>
+                <a:cs typeface="Arial"/>
+              </a:defRPr>
+            </a:pPr>
+            <a:r>
+              <a:rPr sz="2250" b="1">
+                <a:solidFill>
+                  <a:srgbClr val="F1F5F7"/>
+                </a:solidFill>
+                <a:latin typeface="Arial"/>
+                <a:ea typeface="Arial"/>
+                <a:cs typeface="Arial"/>
+              </a:rPr>
+              <a:t>Интеграции</a:t>
+            </a:r>
+          </a:p>
+        </p:txBody>
+      </p:sp>
+      <p:sp>
+        <p:nvSpPr>
+          <p:cNvPr id="7" name="">
+            <a:extLst xmlns:a="http://schemas.openxmlformats.org/drawingml/2006/main">
+              <a:ext uri="{FF2B5EF4-FFF2-40B4-BE49-F238E27FC236}">
+                <a16:creationId xmlns:a16="http://schemas.microsoft.com/office/drawing/2014/main" id="{29A4DE1B-89A7-4F53-B8D9-853A86936D03}"/>
+              </a:ext>
+            </a:extLst>
+          </p:cNvPr>
+          <p:cNvSpPr>
+            <a:spLocks xmlns:a="http://schemas.openxmlformats.org/drawingml/2006/main" noGrp="1"/>
+          </p:cNvSpPr>
+          <p:nvPr/>
+        </p:nvSpPr>
+        <p:spPr>
+          <a:xfrm xmlns:a="http://schemas.openxmlformats.org/drawingml/2006/main">
+            <a:off x="1685925" y="3600450"/>
+            <a:ext cx="9525000" cy="781050"/>
+          </a:xfrm>
+          <a:prstGeom xmlns:a="http://schemas.openxmlformats.org/drawingml/2006/main" prst="rect">
+            <a:avLst/>
+          </a:prstGeom>
+          <a:noFill xmlns:a="http://schemas.openxmlformats.org/drawingml/2006/main"/>
+          <a:ln xmlns:a="http://schemas.openxmlformats.org/drawingml/2006/main" w="0">
+            <a:noFill/>
+          </a:ln>
+        </p:spPr>
+        <p:txBody>
+          <a:bodyPr xmlns:a="http://schemas.openxmlformats.org/drawingml/2006/main">
+            <a:noAutofit/>
+          </a:bodyPr>
+          <a:lstStyle xmlns:a="http://schemas.openxmlformats.org/drawingml/2006/main">
+            <a:defPPr>
+              <a:defRPr sz="1950" b="0">
+                <a:solidFill>
+                  <a:srgbClr val="B0BDC5"/>
+                </a:solidFill>
+                <a:latin typeface="Arial"/>
+                <a:ea typeface="Arial"/>
+                <a:cs typeface="Arial"/>
+              </a:defRPr>
+            </a:defPPr>
+          </a:lstStyle>
+          <a:p xmlns:a="http://schemas.openxmlformats.org/drawingml/2006/main">
+            <a:pPr>
+              <a:defRPr sz="1950" b="0">
+                <a:solidFill>
+                  <a:srgbClr val="B0BDC5"/>
+                </a:solidFill>
+                <a:latin typeface="Arial"/>
+                <a:ea typeface="Arial"/>
+                <a:cs typeface="Arial"/>
+              </a:defRPr>
+            </a:pPr>
+            <a:r>
+              <a:rPr sz="1950" b="0">
+                <a:solidFill>
+                  <a:srgbClr val="B0BDC5"/>
+                </a:solidFill>
+                <a:latin typeface="Arial"/>
+                <a:ea typeface="Arial"/>
+                <a:cs typeface="Arial"/>
+              </a:rPr>
+              <a:t>ФСП ID через OIDC, контракт достижений и события для ATS.</a:t>
+            </a:r>
+          </a:p>
+        </p:txBody>
+      </p:sp>
+      <p:sp>
+        <p:nvSpPr>
+          <p:cNvPr id="8" name="">
+            <a:extLst xmlns:a="http://schemas.openxmlformats.org/drawingml/2006/main">
+              <a:ext uri="{FF2B5EF4-FFF2-40B4-BE49-F238E27FC236}">
+                <a16:creationId xmlns:a16="http://schemas.microsoft.com/office/drawing/2014/main" id="{A380E7B6-4151-4E2F-8317-62A236AB1EDA}"/>
+              </a:ext>
+            </a:extLst>
+          </p:cNvPr>
+          <p:cNvSpPr>
+            <a:spLocks xmlns:a="http://schemas.openxmlformats.org/drawingml/2006/main" noGrp="1"/>
+          </p:cNvSpPr>
+          <p:nvPr/>
+        </p:nvSpPr>
+        <p:spPr>
+          <a:xfrm xmlns:a="http://schemas.openxmlformats.org/drawingml/2006/main">
+            <a:off x="685800" y="4610100"/>
+            <a:ext cx="742950" cy="647700"/>
+          </a:xfrm>
+          <a:prstGeom xmlns:a="http://schemas.openxmlformats.org/drawingml/2006/main" prst="rect">
+            <a:avLst/>
+          </a:prstGeom>
+          <a:noFill xmlns:a="http://schemas.openxmlformats.org/drawingml/2006/main"/>
+          <a:ln xmlns:a="http://schemas.openxmlformats.org/drawingml/2006/main" w="0">
+            <a:noFill/>
+          </a:ln>
+        </p:spPr>
+        <p:txBody>
+          <a:bodyPr xmlns:a="http://schemas.openxmlformats.org/drawingml/2006/main">
+            <a:noAutofit/>
+          </a:bodyPr>
+          <a:lstStyle xmlns:a="http://schemas.openxmlformats.org/drawingml/2006/main">
+            <a:defPPr>
+              <a:defRPr sz="3150" b="1">
+                <a:solidFill>
+                  <a:srgbClr val="7496FF"/>
+                </a:solidFill>
+                <a:latin typeface="Arial"/>
+                <a:ea typeface="Arial"/>
+                <a:cs typeface="Arial"/>
+              </a:defRPr>
+            </a:defPPr>
+          </a:lstStyle>
+          <a:p xmlns:a="http://schemas.openxmlformats.org/drawingml/2006/main">
+            <a:pPr>
+              <a:defRPr sz="3150" b="1">
+                <a:solidFill>
+                  <a:srgbClr val="7496FF"/>
+                </a:solidFill>
+                <a:latin typeface="Arial"/>
+                <a:ea typeface="Arial"/>
+                <a:cs typeface="Arial"/>
+              </a:defRPr>
+            </a:pPr>
+            <a:r>
+              <a:rPr sz="3150" b="1">
+                <a:solidFill>
+                  <a:srgbClr val="7496FF"/>
+                </a:solidFill>
+                <a:latin typeface="Arial"/>
+                <a:ea typeface="Arial"/>
+                <a:cs typeface="Arial"/>
+              </a:rPr>
+              <a:t>03</a:t>
+            </a:r>
+          </a:p>
+        </p:txBody>
+      </p:sp>
+      <p:sp>
+        <p:nvSpPr>
+          <p:cNvPr id="9" name="">
+            <a:extLst xmlns:a="http://schemas.openxmlformats.org/drawingml/2006/main">
+              <a:ext uri="{FF2B5EF4-FFF2-40B4-BE49-F238E27FC236}">
+                <a16:creationId xmlns:a16="http://schemas.microsoft.com/office/drawing/2014/main" id="{C8D99FAD-7FD8-4773-A329-DE1DDE0F56A7}"/>
+              </a:ext>
+            </a:extLst>
+          </p:cNvPr>
+          <p:cNvSpPr>
+            <a:spLocks xmlns:a="http://schemas.openxmlformats.org/drawingml/2006/main" noGrp="1"/>
+          </p:cNvSpPr>
+          <p:nvPr/>
+        </p:nvSpPr>
+        <p:spPr>
+          <a:xfrm xmlns:a="http://schemas.openxmlformats.org/drawingml/2006/main">
+            <a:off x="1685925" y="4610100"/>
+            <a:ext cx="9525000" cy="457200"/>
+          </a:xfrm>
+          <a:prstGeom xmlns:a="http://schemas.openxmlformats.org/drawingml/2006/main" prst="rect">
+            <a:avLst/>
+          </a:prstGeom>
+          <a:noFill xmlns:a="http://schemas.openxmlformats.org/drawingml/2006/main"/>
+          <a:ln xmlns:a="http://schemas.openxmlformats.org/drawingml/2006/main" w="0">
+            <a:noFill/>
+          </a:ln>
+        </p:spPr>
+        <p:txBody>
+          <a:bodyPr xmlns:a="http://schemas.openxmlformats.org/drawingml/2006/main">
+            <a:noAutofit/>
+          </a:bodyPr>
+          <a:lstStyle xmlns:a="http://schemas.openxmlformats.org/drawingml/2006/main">
+            <a:defPPr>
+              <a:defRPr sz="2250" b="1">
+                <a:solidFill>
+                  <a:srgbClr val="F1F5F7"/>
+                </a:solidFill>
+                <a:latin typeface="Arial"/>
+                <a:ea typeface="Arial"/>
+                <a:cs typeface="Arial"/>
+              </a:defRPr>
+            </a:defPPr>
+          </a:lstStyle>
+          <a:p xmlns:a="http://schemas.openxmlformats.org/drawingml/2006/main">
+            <a:pPr>
+              <a:defRPr sz="2250" b="1">
+                <a:solidFill>
+                  <a:srgbClr val="F1F5F7"/>
+                </a:solidFill>
+                <a:latin typeface="Arial"/>
+                <a:ea typeface="Arial"/>
+                <a:cs typeface="Arial"/>
+              </a:defRPr>
+            </a:pPr>
+            <a:r>
+              <a:rPr sz="2250" b="1">
+                <a:solidFill>
+                  <a:srgbClr val="F1F5F7"/>
+                </a:solidFill>
+                <a:latin typeface="Arial"/>
+                <a:ea typeface="Arial"/>
+                <a:cs typeface="Arial"/>
+              </a:rPr>
+              <a:t>Внешний стенд</a:t>
+            </a:r>
+          </a:p>
+        </p:txBody>
+      </p:sp>
+      <p:sp>
+        <p:nvSpPr>
+          <p:cNvPr id="10" name="">
+            <a:extLst xmlns:a="http://schemas.openxmlformats.org/drawingml/2006/main">
+              <a:ext uri="{FF2B5EF4-FFF2-40B4-BE49-F238E27FC236}">
+                <a16:creationId xmlns:a16="http://schemas.microsoft.com/office/drawing/2014/main" id="{5A8529C7-0E3C-4BB0-A71C-26DAF792802B}"/>
+              </a:ext>
+            </a:extLst>
+          </p:cNvPr>
+          <p:cNvSpPr>
+            <a:spLocks xmlns:a="http://schemas.openxmlformats.org/drawingml/2006/main" noGrp="1"/>
+          </p:cNvSpPr>
+          <p:nvPr/>
+        </p:nvSpPr>
+        <p:spPr>
+          <a:xfrm xmlns:a="http://schemas.openxmlformats.org/drawingml/2006/main">
+            <a:off x="1685925" y="5153025"/>
+            <a:ext cx="9525000" cy="781050"/>
+          </a:xfrm>
+          <a:prstGeom xmlns:a="http://schemas.openxmlformats.org/drawingml/2006/main" prst="rect">
+            <a:avLst/>
+          </a:prstGeom>
+          <a:noFill xmlns:a="http://schemas.openxmlformats.org/drawingml/2006/main"/>
+          <a:ln xmlns:a="http://schemas.openxmlformats.org/drawingml/2006/main" w="0">
+            <a:noFill/>
+          </a:ln>
+        </p:spPr>
+        <p:txBody>
+          <a:bodyPr xmlns:a="http://schemas.openxmlformats.org/drawingml/2006/main">
+            <a:noAutofit/>
+          </a:bodyPr>
+          <a:lstStyle xmlns:a="http://schemas.openxmlformats.org/drawingml/2006/main">
+            <a:defPPr>
+              <a:defRPr sz="1950" b="0">
+                <a:solidFill>
+                  <a:srgbClr val="B0BDC5"/>
+                </a:solidFill>
+                <a:latin typeface="Arial"/>
+                <a:ea typeface="Arial"/>
+                <a:cs typeface="Arial"/>
+              </a:defRPr>
+            </a:defPPr>
+          </a:lstStyle>
+          <a:p xmlns:a="http://schemas.openxmlformats.org/drawingml/2006/main">
+            <a:pPr>
+              <a:defRPr sz="1950" b="0">
+                <a:solidFill>
+                  <a:srgbClr val="B0BDC5"/>
+                </a:solidFill>
+                <a:latin typeface="Arial"/>
+                <a:ea typeface="Arial"/>
+                <a:cs typeface="Arial"/>
+              </a:defRPr>
+            </a:pPr>
+            <a:r>
+              <a:rPr sz="1950" b="0">
+                <a:solidFill>
+                  <a:srgbClr val="B0BDC5"/>
+                </a:solidFill>
+                <a:latin typeface="Arial"/>
+                <a:ea typeface="Arial"/>
+                <a:cs typeface="Arial"/>
+              </a:rPr>
+              <a:t>Домен, HTTPS, почтовый сервис и база без демоаккаунтов.</a:t>
+            </a:r>
+          </a:p>
+        </p:txBody>
+      </p:sp>
+    </p:spTree>
+    <p:extLst>
+      <p:ext uri="{BB962C8B-B14F-4D97-AF65-F5344CB8AC3E}">
+        <p14:creationId xmlns:p14="http://schemas.microsoft.com/office/powerpoint/2010/main" val="62818205"/>
       </p:ext>
     </p:extLst>
   </p:cSld>
@@ -3787,7 +5214,7 @@
           <p:cNvPr id="11" name="">
             <a:extLst xmlns:a="http://schemas.openxmlformats.org/drawingml/2006/main">
               <a:ext uri="{FF2B5EF4-FFF2-40B4-BE49-F238E27FC236}">
-                <a16:creationId xmlns:a16="http://schemas.microsoft.com/office/drawing/2014/main" id="{D5B642EC-DF2B-4B83-9918-7A3AB7C7F6B1}"/>
+                <a16:creationId xmlns:a16="http://schemas.microsoft.com/office/drawing/2014/main" id="{BEB5B543-7FAD-4E91-8BCC-9FCA6A4C567C}"/>
               </a:ext>
             </a:extLst>
           </p:cNvPr>
@@ -3855,7 +5282,7 @@
           <p:cNvPr id="2" name="">
             <a:extLst xmlns:a="http://schemas.openxmlformats.org/drawingml/2006/main">
               <a:ext uri="{FF2B5EF4-FFF2-40B4-BE49-F238E27FC236}">
-                <a16:creationId xmlns:a16="http://schemas.microsoft.com/office/drawing/2014/main" id="{A48A368E-6DD3-4CD0-B643-B57E9CD1810D}"/>
+                <a16:creationId xmlns:a16="http://schemas.microsoft.com/office/drawing/2014/main" id="{E156B38A-A1BA-4680-99A4-382F96089977}"/>
               </a:ext>
             </a:extLst>
           </p:cNvPr>
@@ -3923,7 +5350,7 @@
           <p:cNvPr id="3" name="">
             <a:extLst xmlns:a="http://schemas.openxmlformats.org/drawingml/2006/main">
               <a:ext uri="{FF2B5EF4-FFF2-40B4-BE49-F238E27FC236}">
-                <a16:creationId xmlns:a16="http://schemas.microsoft.com/office/drawing/2014/main" id="{4C811A00-7FAD-42E7-8B8A-C2406A82F2B1}"/>
+                <a16:creationId xmlns:a16="http://schemas.microsoft.com/office/drawing/2014/main" id="{75B500BC-12C9-4484-9A84-546A06A3BB81}"/>
               </a:ext>
             </a:extLst>
           </p:cNvPr>
@@ -3991,7 +5418,7 @@
           <p:cNvPr id="4" name="">
             <a:extLst xmlns:a="http://schemas.openxmlformats.org/drawingml/2006/main">
               <a:ext uri="{FF2B5EF4-FFF2-40B4-BE49-F238E27FC236}">
-                <a16:creationId xmlns:a16="http://schemas.microsoft.com/office/drawing/2014/main" id="{5B6CF813-330A-40D7-A017-9EB06974B3EA}"/>
+                <a16:creationId xmlns:a16="http://schemas.microsoft.com/office/drawing/2014/main" id="{CECC628C-25AB-4129-9A0D-79B32037CA68}"/>
               </a:ext>
             </a:extLst>
           </p:cNvPr>
@@ -4059,7 +5486,7 @@
           <p:cNvPr id="5" name="">
             <a:extLst xmlns:a="http://schemas.openxmlformats.org/drawingml/2006/main">
               <a:ext uri="{FF2B5EF4-FFF2-40B4-BE49-F238E27FC236}">
-                <a16:creationId xmlns:a16="http://schemas.microsoft.com/office/drawing/2014/main" id="{77BD8C0B-2A19-40D8-A866-8F5F4B83BC3C}"/>
+                <a16:creationId xmlns:a16="http://schemas.microsoft.com/office/drawing/2014/main" id="{FFBE3B46-5395-4065-9FA9-E4046E101500}"/>
               </a:ext>
             </a:extLst>
           </p:cNvPr>
@@ -4127,7 +5554,7 @@
           <p:cNvPr id="6" name="">
             <a:extLst xmlns:a="http://schemas.openxmlformats.org/drawingml/2006/main">
               <a:ext uri="{FF2B5EF4-FFF2-40B4-BE49-F238E27FC236}">
-                <a16:creationId xmlns:a16="http://schemas.microsoft.com/office/drawing/2014/main" id="{8412146D-BEA1-427E-8713-871C8DA46E48}"/>
+                <a16:creationId xmlns:a16="http://schemas.microsoft.com/office/drawing/2014/main" id="{A478C47D-45E3-4918-B2DF-503A1DABAB70}"/>
               </a:ext>
             </a:extLst>
           </p:cNvPr>
@@ -4195,7 +5622,7 @@
           <p:cNvPr id="7" name="">
             <a:extLst xmlns:a="http://schemas.openxmlformats.org/drawingml/2006/main">
               <a:ext uri="{FF2B5EF4-FFF2-40B4-BE49-F238E27FC236}">
-                <a16:creationId xmlns:a16="http://schemas.microsoft.com/office/drawing/2014/main" id="{7FDC893B-93DE-40BB-B778-7AC60936D16A}"/>
+                <a16:creationId xmlns:a16="http://schemas.microsoft.com/office/drawing/2014/main" id="{44747F91-8163-49B8-982B-B27782E880E0}"/>
               </a:ext>
             </a:extLst>
           </p:cNvPr>
@@ -4263,7 +5690,7 @@
           <p:cNvPr id="8" name="">
             <a:extLst xmlns:a="http://schemas.openxmlformats.org/drawingml/2006/main">
               <a:ext uri="{FF2B5EF4-FFF2-40B4-BE49-F238E27FC236}">
-                <a16:creationId xmlns:a16="http://schemas.microsoft.com/office/drawing/2014/main" id="{FE31D961-EDB6-45AD-8BE7-56FF81B240C5}"/>
+                <a16:creationId xmlns:a16="http://schemas.microsoft.com/office/drawing/2014/main" id="{AB287369-D412-4006-AC0A-0783F7889AC4}"/>
               </a:ext>
             </a:extLst>
           </p:cNvPr>
@@ -4331,7 +5758,7 @@
           <p:cNvPr id="9" name="">
             <a:extLst xmlns:a="http://schemas.openxmlformats.org/drawingml/2006/main">
               <a:ext uri="{FF2B5EF4-FFF2-40B4-BE49-F238E27FC236}">
-                <a16:creationId xmlns:a16="http://schemas.microsoft.com/office/drawing/2014/main" id="{785089B2-1A11-4A56-8724-47B77230A07C}"/>
+                <a16:creationId xmlns:a16="http://schemas.microsoft.com/office/drawing/2014/main" id="{F729B348-7E24-47F6-AAB3-482B4B1DB197}"/>
               </a:ext>
             </a:extLst>
           </p:cNvPr>
@@ -4399,7 +5826,7 @@
           <p:cNvPr id="10" name="">
             <a:extLst xmlns:a="http://schemas.openxmlformats.org/drawingml/2006/main">
               <a:ext uri="{FF2B5EF4-FFF2-40B4-BE49-F238E27FC236}">
-                <a16:creationId xmlns:a16="http://schemas.microsoft.com/office/drawing/2014/main" id="{21343F55-A6C5-49AC-9371-F96B2FEFC4FE}"/>
+                <a16:creationId xmlns:a16="http://schemas.microsoft.com/office/drawing/2014/main" id="{F880B727-ED2C-4A7A-9CFC-8514CE48F447}"/>
               </a:ext>
             </a:extLst>
           </p:cNvPr>
@@ -4465,7 +5892,7 @@
     </p:spTree>
     <p:extLst>
       <p:ext uri="{BB962C8B-B14F-4D97-AF65-F5344CB8AC3E}">
-        <p14:creationId xmlns:p14="http://schemas.microsoft.com/office/powerpoint/2010/main" val="1527965050"/>
+        <p14:creationId xmlns:p14="http://schemas.microsoft.com/office/powerpoint/2010/main" val="737886888"/>
       </p:ext>
     </p:extLst>
   </p:cSld>
@@ -4496,7 +5923,7 @@
           <p:cNvPr id="7" name="">
             <a:extLst xmlns:a="http://schemas.openxmlformats.org/drawingml/2006/main">
               <a:ext uri="{FF2B5EF4-FFF2-40B4-BE49-F238E27FC236}">
-                <a16:creationId xmlns:a16="http://schemas.microsoft.com/office/drawing/2014/main" id="{3F46566B-1A4F-4E81-B663-83B387D7D802}"/>
+                <a16:creationId xmlns:a16="http://schemas.microsoft.com/office/drawing/2014/main" id="{80B14BA8-42A1-496E-9678-1E35C33EEFAD}"/>
               </a:ext>
             </a:extLst>
           </p:cNvPr>
@@ -4564,7 +5991,7 @@
           <p:cNvPr id="2" name="">
             <a:extLst xmlns:a="http://schemas.openxmlformats.org/drawingml/2006/main">
               <a:ext uri="{FF2B5EF4-FFF2-40B4-BE49-F238E27FC236}">
-                <a16:creationId xmlns:a16="http://schemas.microsoft.com/office/drawing/2014/main" id="{0C821F84-5E5B-4B7D-A9CC-63BE4DE34C0A}"/>
+                <a16:creationId xmlns:a16="http://schemas.microsoft.com/office/drawing/2014/main" id="{5EF33AB6-2CE0-496D-B558-2B9AA7718F2F}"/>
               </a:ext>
             </a:extLst>
           </p:cNvPr>
@@ -4632,7 +6059,7 @@
           <p:cNvPr id="3" name="">
             <a:extLst xmlns:a="http://schemas.openxmlformats.org/drawingml/2006/main">
               <a:ext uri="{FF2B5EF4-FFF2-40B4-BE49-F238E27FC236}">
-                <a16:creationId xmlns:a16="http://schemas.microsoft.com/office/drawing/2014/main" id="{B285B6C3-D5C0-4258-B25F-4DFD92B33B75}"/>
+                <a16:creationId xmlns:a16="http://schemas.microsoft.com/office/drawing/2014/main" id="{50BF404E-F951-4C16-AC5B-C33330208335}"/>
               </a:ext>
             </a:extLst>
           </p:cNvPr>
@@ -4700,7 +6127,7 @@
           <p:cNvPr id="4" name="">
             <a:extLst xmlns:a="http://schemas.openxmlformats.org/drawingml/2006/main">
               <a:ext uri="{FF2B5EF4-FFF2-40B4-BE49-F238E27FC236}">
-                <a16:creationId xmlns:a16="http://schemas.microsoft.com/office/drawing/2014/main" id="{28B92AB6-7AA0-49EB-B0F7-901863B0B77D}"/>
+                <a16:creationId xmlns:a16="http://schemas.microsoft.com/office/drawing/2014/main" id="{C9C03C42-8281-4701-84AC-2FDCE032DE4A}"/>
               </a:ext>
             </a:extLst>
           </p:cNvPr>
@@ -4768,7 +6195,7 @@
           <p:cNvPr id="5" name="">
             <a:extLst xmlns:a="http://schemas.openxmlformats.org/drawingml/2006/main">
               <a:ext uri="{FF2B5EF4-FFF2-40B4-BE49-F238E27FC236}">
-                <a16:creationId xmlns:a16="http://schemas.microsoft.com/office/drawing/2014/main" id="{EE3712C8-FC95-4E3D-BD19-59FA63ED6744}"/>
+                <a16:creationId xmlns:a16="http://schemas.microsoft.com/office/drawing/2014/main" id="{21679438-FBBC-4A71-A688-B2E1F23A82C0}"/>
               </a:ext>
             </a:extLst>
           </p:cNvPr>
@@ -4859,7 +6286,7 @@
           <p:cNvPr id="6" name="">
             <a:extLst xmlns:a="http://schemas.openxmlformats.org/drawingml/2006/main">
               <a:ext uri="{FF2B5EF4-FFF2-40B4-BE49-F238E27FC236}">
-                <a16:creationId xmlns:a16="http://schemas.microsoft.com/office/drawing/2014/main" id="{FC174A9D-2FAB-4D3E-84DC-65E3A02C9B74}"/>
+                <a16:creationId xmlns:a16="http://schemas.microsoft.com/office/drawing/2014/main" id="{F1D76064-2F8A-43A4-877C-F217DF7B4BB0}"/>
               </a:ext>
             </a:extLst>
           </p:cNvPr>
@@ -4948,7 +6375,7 @@
     </p:spTree>
     <p:extLst>
       <p:ext uri="{BB962C8B-B14F-4D97-AF65-F5344CB8AC3E}">
-        <p14:creationId xmlns:p14="http://schemas.microsoft.com/office/powerpoint/2010/main" val="1903279763"/>
+        <p14:creationId xmlns:p14="http://schemas.microsoft.com/office/powerpoint/2010/main" val="1127870330"/>
       </p:ext>
     </p:extLst>
   </p:cSld>
@@ -4979,7 +6406,7 @@
           <p:cNvPr id="6" name="">
             <a:extLst xmlns:a="http://schemas.openxmlformats.org/drawingml/2006/main">
               <a:ext uri="{FF2B5EF4-FFF2-40B4-BE49-F238E27FC236}">
-                <a16:creationId xmlns:a16="http://schemas.microsoft.com/office/drawing/2014/main" id="{1A710FCC-87DC-4A78-B0FB-F1BAB45A27D4}"/>
+                <a16:creationId xmlns:a16="http://schemas.microsoft.com/office/drawing/2014/main" id="{03DF749B-CA32-4C64-AFD5-19197E8CC85F}"/>
               </a:ext>
             </a:extLst>
           </p:cNvPr>
@@ -5047,7 +6474,7 @@
           <p:cNvPr id="2" name="">
             <a:extLst xmlns:a="http://schemas.openxmlformats.org/drawingml/2006/main">
               <a:ext uri="{FF2B5EF4-FFF2-40B4-BE49-F238E27FC236}">
-                <a16:creationId xmlns:a16="http://schemas.microsoft.com/office/drawing/2014/main" id="{6746E21B-075C-44C3-B892-5A255AC4F261}"/>
+                <a16:creationId xmlns:a16="http://schemas.microsoft.com/office/drawing/2014/main" id="{E3D7D874-0BEA-498B-9D89-BF2D9FCB9EA3}"/>
               </a:ext>
             </a:extLst>
           </p:cNvPr>
@@ -5115,7 +6542,7 @@
           <p:cNvPr id="3" name="Chart">
             <a:extLst xmlns:a="http://schemas.openxmlformats.org/drawingml/2006/main">
               <a:ext uri="{FF2B5EF4-FFF2-40B4-BE49-F238E27FC236}">
-                <a16:creationId xmlns:a16="http://schemas.microsoft.com/office/drawing/2014/main" id="{2E7230A8-994F-4ED8-A191-A61AA14487A4}"/>
+                <a16:creationId xmlns:a16="http://schemas.microsoft.com/office/drawing/2014/main" id="{1E0B9A23-7B1E-4084-A4BC-EB506E1CC83D}"/>
               </a:ext>
             </a:extLst>
           </p:cNvPr>
@@ -5128,7 +6555,7 @@
         </p:xfrm>
         <a:graphic xmlns:a="http://schemas.openxmlformats.org/drawingml/2006/main">
           <a:graphicData uri="http://schemas.openxmlformats.org/drawingml/2006/chart">
-            <c:chart xmlns:r="http://schemas.openxmlformats.org/officeDocument/2006/relationships" xmlns:c="http://schemas.openxmlformats.org/drawingml/2006/chart" r:id="Rf6537c3c85f44d79"/>
+            <c:chart xmlns:r="http://schemas.openxmlformats.org/officeDocument/2006/relationships" xmlns:c="http://schemas.openxmlformats.org/drawingml/2006/chart" r:id="Rd63d2c0adbec4b53"/>
           </a:graphicData>
         </a:graphic>
       </p:graphicFrame>
@@ -5137,7 +6564,7 @@
           <p:cNvPr id="4" name="">
             <a:extLst xmlns:a="http://schemas.openxmlformats.org/drawingml/2006/main">
               <a:ext uri="{FF2B5EF4-FFF2-40B4-BE49-F238E27FC236}">
-                <a16:creationId xmlns:a16="http://schemas.microsoft.com/office/drawing/2014/main" id="{E28156A0-36B6-4753-8C51-344405C2A569}"/>
+                <a16:creationId xmlns:a16="http://schemas.microsoft.com/office/drawing/2014/main" id="{8C0231E6-1976-4565-98C3-EEC4DC4B0D23}"/>
               </a:ext>
             </a:extLst>
           </p:cNvPr>
@@ -5251,7 +6678,7 @@
           <p:cNvPr id="5" name="">
             <a:extLst xmlns:a="http://schemas.openxmlformats.org/drawingml/2006/main">
               <a:ext uri="{FF2B5EF4-FFF2-40B4-BE49-F238E27FC236}">
-                <a16:creationId xmlns:a16="http://schemas.microsoft.com/office/drawing/2014/main" id="{86C77BBD-68A6-45A3-B7AF-6E18F9B78290}"/>
+                <a16:creationId xmlns:a16="http://schemas.microsoft.com/office/drawing/2014/main" id="{A49CFBE7-D658-46DF-B8CF-BEE842AB5719}"/>
               </a:ext>
             </a:extLst>
           </p:cNvPr>
@@ -5317,7 +6744,7 @@
     </p:spTree>
     <p:extLst>
       <p:ext uri="{BB962C8B-B14F-4D97-AF65-F5344CB8AC3E}">
-        <p14:creationId xmlns:p14="http://schemas.microsoft.com/office/powerpoint/2010/main" val="742878219"/>
+        <p14:creationId xmlns:p14="http://schemas.microsoft.com/office/powerpoint/2010/main" val="1486251103"/>
       </p:ext>
     </p:extLst>
   </p:cSld>
@@ -5348,7 +6775,7 @@
           <p:cNvPr id="4" name="">
             <a:extLst xmlns:a="http://schemas.openxmlformats.org/drawingml/2006/main">
               <a:ext uri="{FF2B5EF4-FFF2-40B4-BE49-F238E27FC236}">
-                <a16:creationId xmlns:a16="http://schemas.microsoft.com/office/drawing/2014/main" id="{52928AEC-410E-42CB-BFDF-990B816A684D}"/>
+                <a16:creationId xmlns:a16="http://schemas.microsoft.com/office/drawing/2014/main" id="{B863A13A-48F2-4372-94DF-43B711DB6C2C}"/>
               </a:ext>
             </a:extLst>
           </p:cNvPr>
@@ -5406,7 +6833,7 @@
                 <a:ea typeface="Arial"/>
                 <a:cs typeface="Arial"/>
               </a:rPr>
-              <a:t>Рабочий прототип</a:t>
+              <a:t>Кабинет работодателя</a:t>
             </a:r>
           </a:p>
         </p:txBody>
@@ -5416,7 +6843,7 @@
           <p:cNvPr id="2" name="">
             <a:extLst xmlns:a="http://schemas.openxmlformats.org/drawingml/2006/main">
               <a:ext uri="{FF2B5EF4-FFF2-40B4-BE49-F238E27FC236}">
-                <a16:creationId xmlns:a16="http://schemas.microsoft.com/office/drawing/2014/main" id="{DA3B5337-90E3-4381-8114-0CA0C46D6CC0}"/>
+                <a16:creationId xmlns:a16="http://schemas.microsoft.com/office/drawing/2014/main" id="{CDA6AAD4-563D-4637-9FA8-AD086E086E3D}"/>
               </a:ext>
             </a:extLst>
           </p:cNvPr>
@@ -5426,13 +6853,13 @@
           <p:nvPr/>
         </p:nvPicPr>
         <p:blipFill>
-          <a:blip xmlns:r="http://schemas.openxmlformats.org/officeDocument/2006/relationships" xmlns:a="http://schemas.openxmlformats.org/drawingml/2006/main" r:embed="R766a867d3430403b"/>
+          <a:blip xmlns:r="http://schemas.openxmlformats.org/officeDocument/2006/relationships" xmlns:a="http://schemas.openxmlformats.org/drawingml/2006/main" r:embed="R5f09916e490a4e58"/>
           <a:stretch xmlns:a="http://schemas.openxmlformats.org/drawingml/2006/main"/>
         </p:blipFill>
         <p:spPr>
           <a:xfrm xmlns:a="http://schemas.openxmlformats.org/drawingml/2006/main">
-            <a:off x="1947333" y="1447800"/>
-            <a:ext cx="8297333" cy="4667250"/>
+            <a:off x="2735580" y="1447800"/>
+            <a:ext cx="6720840" cy="4667250"/>
           </a:xfrm>
           <a:prstGeom xmlns:a="http://schemas.openxmlformats.org/drawingml/2006/main" prst="rect">
             <a:avLst/>
@@ -5444,7 +6871,7 @@
           <p:cNvPr id="3" name="">
             <a:extLst xmlns:a="http://schemas.openxmlformats.org/drawingml/2006/main">
               <a:ext uri="{FF2B5EF4-FFF2-40B4-BE49-F238E27FC236}">
-                <a16:creationId xmlns:a16="http://schemas.microsoft.com/office/drawing/2014/main" id="{A55AE360-F45D-43B5-97E1-9D4943305AD2}"/>
+                <a16:creationId xmlns:a16="http://schemas.microsoft.com/office/drawing/2014/main" id="{21F72904-A5C9-4303-BEE8-019CCDC9E994}"/>
               </a:ext>
             </a:extLst>
           </p:cNvPr>
@@ -5502,7 +6929,7 @@
                 <a:ea typeface="Arial"/>
                 <a:cs typeface="Arial"/>
               </a:rPr>
-              <a:t>Два кабинета. Поиск, профиль и приглашения с зарплатой.</a:t>
+              <a:t>Потребность, категории и этапы найма в одном рабочем пространстве.</a:t>
             </a:r>
           </a:p>
         </p:txBody>
@@ -5510,7 +6937,7 @@
     </p:spTree>
     <p:extLst>
       <p:ext uri="{BB962C8B-B14F-4D97-AF65-F5344CB8AC3E}">
-        <p14:creationId xmlns:p14="http://schemas.microsoft.com/office/powerpoint/2010/main" val="1641285497"/>
+        <p14:creationId xmlns:p14="http://schemas.microsoft.com/office/powerpoint/2010/main" val="1811940334"/>
       </p:ext>
     </p:extLst>
   </p:cSld>
@@ -5538,10 +6965,10 @@
       </p:grpSpPr>
       <p:sp>
         <p:nvSpPr>
-          <p:cNvPr id="6" name="">
+          <p:cNvPr id="4" name="">
             <a:extLst xmlns:a="http://schemas.openxmlformats.org/drawingml/2006/main">
               <a:ext uri="{FF2B5EF4-FFF2-40B4-BE49-F238E27FC236}">
-                <a16:creationId xmlns:a16="http://schemas.microsoft.com/office/drawing/2014/main" id="{8F85888C-CA5E-4BFA-99B0-C1D088ABE025}"/>
+                <a16:creationId xmlns:a16="http://schemas.microsoft.com/office/drawing/2014/main" id="{80AFF4D5-6FD7-4BFC-9A4C-96EE7AD77171}"/>
               </a:ext>
             </a:extLst>
           </p:cNvPr>
@@ -5599,29 +7026,57 @@
                 <a:ea typeface="Arial"/>
                 <a:cs typeface="Arial"/>
               </a:rPr>
-              <a:t>Проверка вариантов тестов</a:t>
+              <a:t>Сравнение кандидатов</a:t>
             </a:r>
           </a:p>
         </p:txBody>
       </p:sp>
-      <p:sp>
-        <p:nvSpPr>
+      <p:pic>
+        <p:nvPicPr>
           <p:cNvPr id="2" name="">
             <a:extLst xmlns:a="http://schemas.openxmlformats.org/drawingml/2006/main">
               <a:ext uri="{FF2B5EF4-FFF2-40B4-BE49-F238E27FC236}">
-                <a16:creationId xmlns:a16="http://schemas.microsoft.com/office/drawing/2014/main" id="{FF2CB0F4-4E6E-4145-A1BF-AB342A059DFC}"/>
+                <a16:creationId xmlns:a16="http://schemas.microsoft.com/office/drawing/2014/main" id="{8724D8ED-CAB5-4B5A-A6FF-7A5FD0783101}"/>
               </a:ext>
             </a:extLst>
           </p:cNvPr>
-          <p:cNvSpPr>
-            <a:spLocks xmlns:a="http://schemas.openxmlformats.org/drawingml/2006/main" noGrp="1"/>
-          </p:cNvSpPr>
+          <p:cNvPicPr>
+            <a:picLocks xmlns:a="http://schemas.openxmlformats.org/drawingml/2006/main" noChangeAspect="1"/>
+          </p:cNvPicPr>
           <p:nvPr/>
-        </p:nvSpPr>
+        </p:nvPicPr>
+        <p:blipFill>
+          <a:blip xmlns:r="http://schemas.openxmlformats.org/officeDocument/2006/relationships" xmlns:a="http://schemas.openxmlformats.org/drawingml/2006/main" r:embed="R835cef9d789c4f25"/>
+          <a:stretch xmlns:a="http://schemas.openxmlformats.org/drawingml/2006/main"/>
+        </p:blipFill>
         <p:spPr>
           <a:xfrm xmlns:a="http://schemas.openxmlformats.org/drawingml/2006/main">
-            <a:off x="685800" y="1619250"/>
-            <a:ext cx="10001250" cy="1295400"/>
+            <a:off x="2735580" y="1447800"/>
+            <a:ext cx="6720840" cy="4667250"/>
+          </a:xfrm>
+          <a:prstGeom xmlns:a="http://schemas.openxmlformats.org/drawingml/2006/main" prst="rect">
+            <a:avLst/>
+          </a:prstGeom>
+        </p:spPr>
+      </p:pic>
+      <p:sp>
+        <p:nvSpPr>
+          <p:cNvPr id="3" name="">
+            <a:extLst xmlns:a="http://schemas.openxmlformats.org/drawingml/2006/main">
+              <a:ext uri="{FF2B5EF4-FFF2-40B4-BE49-F238E27FC236}">
+                <a16:creationId xmlns:a16="http://schemas.microsoft.com/office/drawing/2014/main" id="{DC8D738B-6145-434B-93BB-A274076E24AE}"/>
+              </a:ext>
+            </a:extLst>
+          </p:cNvPr>
+          <p:cNvSpPr>
+            <a:spLocks xmlns:a="http://schemas.openxmlformats.org/drawingml/2006/main" noGrp="1"/>
+          </p:cNvSpPr>
+          <p:nvPr/>
+        </p:nvSpPr>
+        <p:spPr>
+          <a:xfrm xmlns:a="http://schemas.openxmlformats.org/drawingml/2006/main">
+            <a:off x="685800" y="6296025"/>
+            <a:ext cx="10572750" cy="285750"/>
           </a:xfrm>
           <a:prstGeom xmlns:a="http://schemas.openxmlformats.org/drawingml/2006/main" prst="rect">
             <a:avLst/>
@@ -5637,9 +7092,9 @@
           </a:bodyPr>
           <a:lstStyle xmlns:a="http://schemas.openxmlformats.org/drawingml/2006/main">
             <a:defPPr>
-              <a:defRPr sz="7500" b="1">
-                <a:solidFill>
-                  <a:srgbClr val="7496FF"/>
+              <a:defRPr sz="1725" b="0">
+                <a:solidFill>
+                  <a:srgbClr val="B0BDC5"/>
                 </a:solidFill>
                 <a:latin typeface="Arial"/>
                 <a:ea typeface="Arial"/>
@@ -5649,9 +7104,9 @@
           </a:lstStyle>
           <a:p xmlns:a="http://schemas.openxmlformats.org/drawingml/2006/main">
             <a:pPr>
-              <a:defRPr sz="7500" b="1">
-                <a:solidFill>
-                  <a:srgbClr val="7496FF"/>
+              <a:defRPr sz="1725" b="0">
+                <a:solidFill>
+                  <a:srgbClr val="B0BDC5"/>
                 </a:solidFill>
                 <a:latin typeface="Arial"/>
                 <a:ea typeface="Arial"/>
@@ -5659,265 +7114,15 @@
               </a:defRPr>
             </a:pPr>
             <a:r>
-              <a:rPr sz="7500" b="1">
-                <a:solidFill>
-                  <a:srgbClr val="7496FF"/>
+              <a:rPr sz="1725" b="0">
+                <a:solidFill>
+                  <a:srgbClr val="B0BDC5"/>
                 </a:solidFill>
                 <a:latin typeface="Arial"/>
                 <a:ea typeface="Arial"/>
                 <a:cs typeface="Arial"/>
               </a:rPr>
-              <a:t>3,4%</a:t>
-            </a:r>
-          </a:p>
-        </p:txBody>
-      </p:sp>
-      <p:sp>
-        <p:nvSpPr>
-          <p:cNvPr id="3" name="">
-            <a:extLst xmlns:a="http://schemas.openxmlformats.org/drawingml/2006/main">
-              <a:ext uri="{FF2B5EF4-FFF2-40B4-BE49-F238E27FC236}">
-                <a16:creationId xmlns:a16="http://schemas.microsoft.com/office/drawing/2014/main" id="{63618DCB-CFDB-4D3A-927F-F203B05885D7}"/>
-              </a:ext>
-            </a:extLst>
-          </p:cNvPr>
-          <p:cNvSpPr>
-            <a:spLocks xmlns:a="http://schemas.openxmlformats.org/drawingml/2006/main" noGrp="1"/>
-          </p:cNvSpPr>
-          <p:nvPr/>
-        </p:nvSpPr>
-        <p:spPr>
-          <a:xfrm xmlns:a="http://schemas.openxmlformats.org/drawingml/2006/main">
-            <a:off x="723900" y="3152775"/>
-            <a:ext cx="10477500" cy="1200150"/>
-          </a:xfrm>
-          <a:prstGeom xmlns:a="http://schemas.openxmlformats.org/drawingml/2006/main" prst="rect">
-            <a:avLst/>
-          </a:prstGeom>
-          <a:noFill xmlns:a="http://schemas.openxmlformats.org/drawingml/2006/main"/>
-          <a:ln xmlns:a="http://schemas.openxmlformats.org/drawingml/2006/main" w="0">
-            <a:noFill/>
-          </a:ln>
-        </p:spPr>
-        <p:txBody>
-          <a:bodyPr xmlns:a="http://schemas.openxmlformats.org/drawingml/2006/main">
-            <a:noAutofit/>
-          </a:bodyPr>
-          <a:lstStyle xmlns:a="http://schemas.openxmlformats.org/drawingml/2006/main">
-            <a:defPPr>
-              <a:defRPr sz="2850" b="0">
-                <a:solidFill>
-                  <a:srgbClr val="F1F5F7"/>
-                </a:solidFill>
-                <a:latin typeface="Arial"/>
-                <a:ea typeface="Arial"/>
-                <a:cs typeface="Arial"/>
-              </a:defRPr>
-            </a:defPPr>
-          </a:lstStyle>
-          <a:p xmlns:a="http://schemas.openxmlformats.org/drawingml/2006/main">
-            <a:pPr>
-              <a:defRPr sz="2850" b="0">
-                <a:solidFill>
-                  <a:srgbClr val="F1F5F7"/>
-                </a:solidFill>
-                <a:latin typeface="Arial"/>
-                <a:ea typeface="Arial"/>
-                <a:cs typeface="Arial"/>
-              </a:defRPr>
-            </a:pPr>
-            <a:r>
-              <a:rPr sz="2850" b="0">
-                <a:solidFill>
-                  <a:srgbClr val="F1F5F7"/>
-                </a:solidFill>
-                <a:latin typeface="Arial"/>
-                <a:ea typeface="Arial"/>
-                <a:cs typeface="Arial"/>
-              </a:rPr>
-              <a:t>31 из 900 новых тестов прошли</a:t>
-            </a:r>
-          </a:p>
-          <a:p xmlns:a="http://schemas.openxmlformats.org/drawingml/2006/main">
-            <a:pPr>
-              <a:defRPr sz="2850" b="0">
-                <a:solidFill>
-                  <a:srgbClr val="F1F5F7"/>
-                </a:solidFill>
-                <a:latin typeface="Arial"/>
-                <a:ea typeface="Arial"/>
-                <a:cs typeface="Arial"/>
-              </a:defRPr>
-            </a:pPr>
-            <a:r>
-              <a:rPr sz="2850" b="0">
-                <a:solidFill>
-                  <a:srgbClr val="F1F5F7"/>
-                </a:solidFill>
-                <a:latin typeface="Arial"/>
-                <a:ea typeface="Arial"/>
-                <a:cs typeface="Arial"/>
-              </a:rPr>
-              <a:t>с готовым ключом от другого варианта</a:t>
-            </a:r>
-          </a:p>
-        </p:txBody>
-      </p:sp>
-      <p:sp>
-        <p:nvSpPr>
-          <p:cNvPr id="4" name="">
-            <a:extLst xmlns:a="http://schemas.openxmlformats.org/drawingml/2006/main">
-              <a:ext uri="{FF2B5EF4-FFF2-40B4-BE49-F238E27FC236}">
-                <a16:creationId xmlns:a16="http://schemas.microsoft.com/office/drawing/2014/main" id="{26FD6107-9784-404C-9A57-83D4AAAA7DFB}"/>
-              </a:ext>
-            </a:extLst>
-          </p:cNvPr>
-          <p:cNvSpPr>
-            <a:spLocks xmlns:a="http://schemas.openxmlformats.org/drawingml/2006/main" noGrp="1"/>
-          </p:cNvSpPr>
-          <p:nvPr/>
-        </p:nvSpPr>
-        <p:spPr>
-          <a:xfrm xmlns:a="http://schemas.openxmlformats.org/drawingml/2006/main">
-            <a:off x="723900" y="4695825"/>
-            <a:ext cx="10477500" cy="523875"/>
-          </a:xfrm>
-          <a:prstGeom xmlns:a="http://schemas.openxmlformats.org/drawingml/2006/main" prst="rect">
-            <a:avLst/>
-          </a:prstGeom>
-          <a:noFill xmlns:a="http://schemas.openxmlformats.org/drawingml/2006/main"/>
-          <a:ln xmlns:a="http://schemas.openxmlformats.org/drawingml/2006/main" w="0">
-            <a:noFill/>
-          </a:ln>
-        </p:spPr>
-        <p:txBody>
-          <a:bodyPr xmlns:a="http://schemas.openxmlformats.org/drawingml/2006/main">
-            <a:noAutofit/>
-          </a:bodyPr>
-          <a:lstStyle xmlns:a="http://schemas.openxmlformats.org/drawingml/2006/main">
-            <a:defPPr>
-              <a:defRPr sz="2175" b="0">
-                <a:solidFill>
-                  <a:srgbClr val="B0BDC5"/>
-                </a:solidFill>
-                <a:latin typeface="Arial"/>
-                <a:ea typeface="Arial"/>
-                <a:cs typeface="Arial"/>
-              </a:defRPr>
-            </a:defPPr>
-          </a:lstStyle>
-          <a:p xmlns:a="http://schemas.openxmlformats.org/drawingml/2006/main">
-            <a:pPr>
-              <a:defRPr sz="2175" b="0">
-                <a:solidFill>
-                  <a:srgbClr val="B0BDC5"/>
-                </a:solidFill>
-                <a:latin typeface="Arial"/>
-                <a:ea typeface="Arial"/>
-                <a:cs typeface="Arial"/>
-              </a:defRPr>
-            </a:pPr>
-            <a:r>
-              <a:rPr sz="2175" b="0">
-                <a:solidFill>
-                  <a:srgbClr val="B0BDC5"/>
-                </a:solidFill>
-                <a:latin typeface="Arial"/>
-                <a:ea typeface="Arial"/>
-                <a:cs typeface="Arial"/>
-              </a:rPr>
-              <a:t>Условия меняются при сохранении общего плана категории.</a:t>
-            </a:r>
-          </a:p>
-        </p:txBody>
-      </p:sp>
-      <p:sp>
-        <p:nvSpPr>
-          <p:cNvPr id="5" name="">
-            <a:extLst xmlns:a="http://schemas.openxmlformats.org/drawingml/2006/main">
-              <a:ext uri="{FF2B5EF4-FFF2-40B4-BE49-F238E27FC236}">
-                <a16:creationId xmlns:a16="http://schemas.microsoft.com/office/drawing/2014/main" id="{7F723C9E-48B3-408F-89B6-EB1ACCB2D6A6}"/>
-              </a:ext>
-            </a:extLst>
-          </p:cNvPr>
-          <p:cNvSpPr>
-            <a:spLocks xmlns:a="http://schemas.openxmlformats.org/drawingml/2006/main" noGrp="1"/>
-          </p:cNvSpPr>
-          <p:nvPr/>
-        </p:nvSpPr>
-        <p:spPr>
-          <a:xfrm xmlns:a="http://schemas.openxmlformats.org/drawingml/2006/main">
-            <a:off x="723900" y="5600700"/>
-            <a:ext cx="10477500" cy="847725"/>
-          </a:xfrm>
-          <a:prstGeom xmlns:a="http://schemas.openxmlformats.org/drawingml/2006/main" prst="rect">
-            <a:avLst/>
-          </a:prstGeom>
-          <a:noFill xmlns:a="http://schemas.openxmlformats.org/drawingml/2006/main"/>
-          <a:ln xmlns:a="http://schemas.openxmlformats.org/drawingml/2006/main" w="0">
-            <a:noFill/>
-          </a:ln>
-        </p:spPr>
-        <p:txBody>
-          <a:bodyPr xmlns:a="http://schemas.openxmlformats.org/drawingml/2006/main">
-            <a:noAutofit/>
-          </a:bodyPr>
-          <a:lstStyle xmlns:a="http://schemas.openxmlformats.org/drawingml/2006/main">
-            <a:defPPr>
-              <a:defRPr sz="2025" b="0">
-                <a:solidFill>
-                  <a:srgbClr val="B0BDC5"/>
-                </a:solidFill>
-                <a:latin typeface="Arial"/>
-                <a:ea typeface="Arial"/>
-                <a:cs typeface="Arial"/>
-              </a:defRPr>
-            </a:defPPr>
-          </a:lstStyle>
-          <a:p xmlns:a="http://schemas.openxmlformats.org/drawingml/2006/main">
-            <a:pPr>
-              <a:defRPr sz="2025" b="0">
-                <a:solidFill>
-                  <a:srgbClr val="B0BDC5"/>
-                </a:solidFill>
-                <a:latin typeface="Arial"/>
-                <a:ea typeface="Arial"/>
-                <a:cs typeface="Arial"/>
-              </a:defRPr>
-            </a:pPr>
-            <a:r>
-              <a:rPr sz="2025" b="0">
-                <a:solidFill>
-                  <a:srgbClr val="B0BDC5"/>
-                </a:solidFill>
-                <a:latin typeface="Arial"/>
-                <a:ea typeface="Arial"/>
-                <a:cs typeface="Arial"/>
-              </a:rPr>
-              <a:t>Точность грейдов и сопоставимость сложности</a:t>
-            </a:r>
-          </a:p>
-          <a:p xmlns:a="http://schemas.openxmlformats.org/drawingml/2006/main">
-            <a:pPr>
-              <a:defRPr sz="2025" b="0">
-                <a:solidFill>
-                  <a:srgbClr val="B0BDC5"/>
-                </a:solidFill>
-                <a:latin typeface="Arial"/>
-                <a:ea typeface="Arial"/>
-                <a:cs typeface="Arial"/>
-              </a:defRPr>
-            </a:pPr>
-            <a:r>
-              <a:rPr sz="2025" b="0">
-                <a:solidFill>
-                  <a:srgbClr val="B0BDC5"/>
-                </a:solidFill>
-                <a:latin typeface="Arial"/>
-                <a:ea typeface="Arial"/>
-                <a:cs typeface="Arial"/>
-              </a:rPr>
-              <a:t>ещё требуют проверки экспертами и кандидатами.</a:t>
+              <a:t>До трёх профилей рядом. Видно совпадение и темы для уточнения.</a:t>
             </a:r>
           </a:p>
         </p:txBody>
@@ -5925,7 +7130,7 @@
     </p:spTree>
     <p:extLst>
       <p:ext uri="{BB962C8B-B14F-4D97-AF65-F5344CB8AC3E}">
-        <p14:creationId xmlns:p14="http://schemas.microsoft.com/office/powerpoint/2010/main" val="1013308899"/>
+        <p14:creationId xmlns:p14="http://schemas.microsoft.com/office/powerpoint/2010/main" val="1736061607"/>
       </p:ext>
     </p:extLst>
   </p:cSld>
@@ -5953,10 +7158,10 @@
       </p:grpSpPr>
       <p:sp>
         <p:nvSpPr>
-          <p:cNvPr id="8" name="">
+          <p:cNvPr id="6" name="">
             <a:extLst xmlns:a="http://schemas.openxmlformats.org/drawingml/2006/main">
               <a:ext uri="{FF2B5EF4-FFF2-40B4-BE49-F238E27FC236}">
-                <a16:creationId xmlns:a16="http://schemas.microsoft.com/office/drawing/2014/main" id="{1D2DA9AE-ED4A-4B49-98E5-876B2AD17A6E}"/>
+                <a16:creationId xmlns:a16="http://schemas.microsoft.com/office/drawing/2014/main" id="{80EED391-E4C5-4FA2-B4A3-2DF3EE2B207D}"/>
               </a:ext>
             </a:extLst>
           </p:cNvPr>
@@ -6014,7 +7219,7 @@
                 <a:ea typeface="Arial"/>
                 <a:cs typeface="Arial"/>
               </a:rPr>
-              <a:t>Стек и хранение</a:t>
+              <a:t>Проверка вариантов тестов</a:t>
             </a:r>
           </a:p>
         </p:txBody>
@@ -6024,7 +7229,7 @@
           <p:cNvPr id="2" name="">
             <a:extLst xmlns:a="http://schemas.openxmlformats.org/drawingml/2006/main">
               <a:ext uri="{FF2B5EF4-FFF2-40B4-BE49-F238E27FC236}">
-                <a16:creationId xmlns:a16="http://schemas.microsoft.com/office/drawing/2014/main" id="{4995F361-AA89-4569-BF1F-5222638C03AA}"/>
+                <a16:creationId xmlns:a16="http://schemas.microsoft.com/office/drawing/2014/main" id="{3FADD766-70F6-41A7-A8A3-D9A8736D146E}"/>
               </a:ext>
             </a:extLst>
           </p:cNvPr>
@@ -6035,8 +7240,8 @@
         </p:nvSpPr>
         <p:spPr>
           <a:xfrm xmlns:a="http://schemas.openxmlformats.org/drawingml/2006/main">
-            <a:off x="685800" y="1609725"/>
-            <a:ext cx="10382250" cy="619125"/>
+            <a:off x="685800" y="1619250"/>
+            <a:ext cx="10001250" cy="1295400"/>
           </a:xfrm>
           <a:prstGeom xmlns:a="http://schemas.openxmlformats.org/drawingml/2006/main" prst="rect">
             <a:avLst/>
@@ -6052,7 +7257,7 @@
           </a:bodyPr>
           <a:lstStyle xmlns:a="http://schemas.openxmlformats.org/drawingml/2006/main">
             <a:defPPr>
-              <a:defRPr sz="3225" b="1">
+              <a:defRPr sz="7500" b="1">
                 <a:solidFill>
                   <a:srgbClr val="7496FF"/>
                 </a:solidFill>
@@ -6064,7 +7269,7 @@
           </a:lstStyle>
           <a:p xmlns:a="http://schemas.openxmlformats.org/drawingml/2006/main">
             <a:pPr>
-              <a:defRPr sz="3225" b="1">
+              <a:defRPr sz="7500" b="1">
                 <a:solidFill>
                   <a:srgbClr val="7496FF"/>
                 </a:solidFill>
@@ -6074,7 +7279,7 @@
               </a:defRPr>
             </a:pPr>
             <a:r>
-              <a:rPr sz="3225" b="1">
+              <a:rPr sz="7500" b="1">
                 <a:solidFill>
                   <a:srgbClr val="7496FF"/>
                 </a:solidFill>
@@ -6082,7 +7287,7 @@
                 <a:ea typeface="Arial"/>
                 <a:cs typeface="Arial"/>
               </a:rPr>
-              <a:t>React + TypeScript</a:t>
+              <a:t>0,3%</a:t>
             </a:r>
           </a:p>
         </p:txBody>
@@ -6092,7 +7297,7 @@
           <p:cNvPr id="3" name="">
             <a:extLst xmlns:a="http://schemas.openxmlformats.org/drawingml/2006/main">
               <a:ext uri="{FF2B5EF4-FFF2-40B4-BE49-F238E27FC236}">
-                <a16:creationId xmlns:a16="http://schemas.microsoft.com/office/drawing/2014/main" id="{C7D1D7D2-7F36-4A6A-ADE3-F27A36CD2898}"/>
+                <a16:creationId xmlns:a16="http://schemas.microsoft.com/office/drawing/2014/main" id="{353A4C41-E52D-4FE4-93F4-C4C61A27DF0F}"/>
               </a:ext>
             </a:extLst>
           </p:cNvPr>
@@ -6103,8 +7308,8 @@
         </p:nvSpPr>
         <p:spPr>
           <a:xfrm xmlns:a="http://schemas.openxmlformats.org/drawingml/2006/main">
-            <a:off x="685800" y="2333625"/>
-            <a:ext cx="10382250" cy="476250"/>
+            <a:off x="723900" y="3152775"/>
+            <a:ext cx="10477500" cy="1200150"/>
           </a:xfrm>
           <a:prstGeom xmlns:a="http://schemas.openxmlformats.org/drawingml/2006/main" prst="rect">
             <a:avLst/>
@@ -6120,9 +7325,9 @@
           </a:bodyPr>
           <a:lstStyle xmlns:a="http://schemas.openxmlformats.org/drawingml/2006/main">
             <a:defPPr>
-              <a:defRPr sz="2175" b="0">
-                <a:solidFill>
-                  <a:srgbClr val="B0BDC5"/>
+              <a:defRPr sz="2850" b="0">
+                <a:solidFill>
+                  <a:srgbClr val="F1F5F7"/>
                 </a:solidFill>
                 <a:latin typeface="Arial"/>
                 <a:ea typeface="Arial"/>
@@ -6132,9 +7337,9 @@
           </a:lstStyle>
           <a:p xmlns:a="http://schemas.openxmlformats.org/drawingml/2006/main">
             <a:pPr>
-              <a:defRPr sz="2175" b="0">
-                <a:solidFill>
-                  <a:srgbClr val="B0BDC5"/>
+              <a:defRPr sz="2850" b="0">
+                <a:solidFill>
+                  <a:srgbClr val="F1F5F7"/>
                 </a:solidFill>
                 <a:latin typeface="Arial"/>
                 <a:ea typeface="Arial"/>
@@ -6142,15 +7347,38 @@
               </a:defRPr>
             </a:pPr>
             <a:r>
-              <a:rPr sz="2175" b="0">
-                <a:solidFill>
-                  <a:srgbClr val="B0BDC5"/>
+              <a:rPr sz="2850" b="0">
+                <a:solidFill>
+                  <a:srgbClr val="F1F5F7"/>
                 </a:solidFill>
                 <a:latin typeface="Arial"/>
                 <a:ea typeface="Arial"/>
                 <a:cs typeface="Arial"/>
               </a:rPr>
-              <a:t>Vite, Tailwind, TanStack Query</a:t>
+              <a:t>3 из 900 новых тестов прошли</a:t>
+            </a:r>
+          </a:p>
+          <a:p xmlns:a="http://schemas.openxmlformats.org/drawingml/2006/main">
+            <a:pPr>
+              <a:defRPr sz="2850" b="0">
+                <a:solidFill>
+                  <a:srgbClr val="F1F5F7"/>
+                </a:solidFill>
+                <a:latin typeface="Arial"/>
+                <a:ea typeface="Arial"/>
+                <a:cs typeface="Arial"/>
+              </a:defRPr>
+            </a:pPr>
+            <a:r>
+              <a:rPr sz="2850" b="0">
+                <a:solidFill>
+                  <a:srgbClr val="F1F5F7"/>
+                </a:solidFill>
+                <a:latin typeface="Arial"/>
+                <a:ea typeface="Arial"/>
+                <a:cs typeface="Arial"/>
+              </a:rPr>
+              <a:t>с готовым ключом от другого варианта</a:t>
             </a:r>
           </a:p>
         </p:txBody>
@@ -6160,7 +7388,7 @@
           <p:cNvPr id="4" name="">
             <a:extLst xmlns:a="http://schemas.openxmlformats.org/drawingml/2006/main">
               <a:ext uri="{FF2B5EF4-FFF2-40B4-BE49-F238E27FC236}">
-                <a16:creationId xmlns:a16="http://schemas.microsoft.com/office/drawing/2014/main" id="{61CD55DC-357B-4577-85A7-EA0DCE789B66}"/>
+                <a16:creationId xmlns:a16="http://schemas.microsoft.com/office/drawing/2014/main" id="{8889998D-9352-4BCD-801D-D95CEF4543FD}"/>
               </a:ext>
             </a:extLst>
           </p:cNvPr>
@@ -6171,8 +7399,8 @@
         </p:nvSpPr>
         <p:spPr>
           <a:xfrm xmlns:a="http://schemas.openxmlformats.org/drawingml/2006/main">
-            <a:off x="685800" y="3238500"/>
-            <a:ext cx="10382250" cy="619125"/>
+            <a:off x="723900" y="4695825"/>
+            <a:ext cx="10477500" cy="523875"/>
           </a:xfrm>
           <a:prstGeom xmlns:a="http://schemas.openxmlformats.org/drawingml/2006/main" prst="rect">
             <a:avLst/>
@@ -6188,9 +7416,9 @@
           </a:bodyPr>
           <a:lstStyle xmlns:a="http://schemas.openxmlformats.org/drawingml/2006/main">
             <a:defPPr>
-              <a:defRPr sz="3225" b="1">
-                <a:solidFill>
-                  <a:srgbClr val="F1F5F7"/>
+              <a:defRPr sz="2175" b="0">
+                <a:solidFill>
+                  <a:srgbClr val="B0BDC5"/>
                 </a:solidFill>
                 <a:latin typeface="Arial"/>
                 <a:ea typeface="Arial"/>
@@ -6200,9 +7428,9 @@
           </a:lstStyle>
           <a:p xmlns:a="http://schemas.openxmlformats.org/drawingml/2006/main">
             <a:pPr>
-              <a:defRPr sz="3225" b="1">
-                <a:solidFill>
-                  <a:srgbClr val="F1F5F7"/>
+              <a:defRPr sz="2175" b="0">
+                <a:solidFill>
+                  <a:srgbClr val="B0BDC5"/>
                 </a:solidFill>
                 <a:latin typeface="Arial"/>
                 <a:ea typeface="Arial"/>
@@ -6210,15 +7438,15 @@
               </a:defRPr>
             </a:pPr>
             <a:r>
-              <a:rPr sz="3225" b="1">
-                <a:solidFill>
-                  <a:srgbClr val="F1F5F7"/>
+              <a:rPr sz="2175" b="0">
+                <a:solidFill>
+                  <a:srgbClr val="B0BDC5"/>
                 </a:solidFill>
                 <a:latin typeface="Arial"/>
                 <a:ea typeface="Arial"/>
                 <a:cs typeface="Arial"/>
               </a:rPr>
-              <a:t>Go + chi + Huma</a:t>
+              <a:t>Условия меняются при сохранении общего плана категории.</a:t>
             </a:r>
           </a:p>
         </p:txBody>
@@ -6228,7 +7456,7 @@
           <p:cNvPr id="5" name="">
             <a:extLst xmlns:a="http://schemas.openxmlformats.org/drawingml/2006/main">
               <a:ext uri="{FF2B5EF4-FFF2-40B4-BE49-F238E27FC236}">
-                <a16:creationId xmlns:a16="http://schemas.microsoft.com/office/drawing/2014/main" id="{C33586FB-9CC9-4C32-A15B-A73B4A5A8517}"/>
+                <a16:creationId xmlns:a16="http://schemas.microsoft.com/office/drawing/2014/main" id="{CD2C3A55-E8C3-4E5F-AFBA-9347C40D0EEB}"/>
               </a:ext>
             </a:extLst>
           </p:cNvPr>
@@ -6239,8 +7467,8 @@
         </p:nvSpPr>
         <p:spPr>
           <a:xfrm xmlns:a="http://schemas.openxmlformats.org/drawingml/2006/main">
-            <a:off x="685800" y="3971925"/>
-            <a:ext cx="10382250" cy="476250"/>
+            <a:off x="723900" y="5600700"/>
+            <a:ext cx="10477500" cy="847725"/>
           </a:xfrm>
           <a:prstGeom xmlns:a="http://schemas.openxmlformats.org/drawingml/2006/main" prst="rect">
             <a:avLst/>
@@ -6256,7 +7484,7 @@
           </a:bodyPr>
           <a:lstStyle xmlns:a="http://schemas.openxmlformats.org/drawingml/2006/main">
             <a:defPPr>
-              <a:defRPr sz="2175" b="0">
+              <a:defRPr sz="2025" b="0">
                 <a:solidFill>
                   <a:srgbClr val="B0BDC5"/>
                 </a:solidFill>
@@ -6268,7 +7496,7 @@
           </a:lstStyle>
           <a:p xmlns:a="http://schemas.openxmlformats.org/drawingml/2006/main">
             <a:pPr>
-              <a:defRPr sz="2175" b="0">
+              <a:defRPr sz="2025" b="0">
                 <a:solidFill>
                   <a:srgbClr val="B0BDC5"/>
                 </a:solidFill>
@@ -6278,7 +7506,7 @@
               </a:defRPr>
             </a:pPr>
             <a:r>
-              <a:rPr sz="2175" b="0">
+              <a:rPr sz="2025" b="0">
                 <a:solidFill>
                   <a:srgbClr val="B0BDC5"/>
                 </a:solidFill>
@@ -6286,59 +7514,14 @@
                 <a:ea typeface="Arial"/>
                 <a:cs typeface="Arial"/>
               </a:rPr>
-              <a:t>Модульный монолит, OpenAPI, SMTP outbox</a:t>
+              <a:t>Точность грейдов и сопоставимость сложности</a:t>
             </a:r>
           </a:p>
-        </p:txBody>
-      </p:sp>
-      <p:sp>
-        <p:nvSpPr>
-          <p:cNvPr id="6" name="">
-            <a:extLst xmlns:a="http://schemas.openxmlformats.org/drawingml/2006/main">
-              <a:ext uri="{FF2B5EF4-FFF2-40B4-BE49-F238E27FC236}">
-                <a16:creationId xmlns:a16="http://schemas.microsoft.com/office/drawing/2014/main" id="{58582614-5020-4C71-BD52-6922C80556A6}"/>
-              </a:ext>
-            </a:extLst>
-          </p:cNvPr>
-          <p:cNvSpPr>
-            <a:spLocks xmlns:a="http://schemas.openxmlformats.org/drawingml/2006/main" noGrp="1"/>
-          </p:cNvSpPr>
-          <p:nvPr/>
-        </p:nvSpPr>
-        <p:spPr>
-          <a:xfrm xmlns:a="http://schemas.openxmlformats.org/drawingml/2006/main">
-            <a:off x="685800" y="4819650"/>
-            <a:ext cx="10382250" cy="619125"/>
-          </a:xfrm>
-          <a:prstGeom xmlns:a="http://schemas.openxmlformats.org/drawingml/2006/main" prst="rect">
-            <a:avLst/>
-          </a:prstGeom>
-          <a:noFill xmlns:a="http://schemas.openxmlformats.org/drawingml/2006/main"/>
-          <a:ln xmlns:a="http://schemas.openxmlformats.org/drawingml/2006/main" w="0">
-            <a:noFill/>
-          </a:ln>
-        </p:spPr>
-        <p:txBody>
-          <a:bodyPr xmlns:a="http://schemas.openxmlformats.org/drawingml/2006/main">
-            <a:noAutofit/>
-          </a:bodyPr>
-          <a:lstStyle xmlns:a="http://schemas.openxmlformats.org/drawingml/2006/main">
-            <a:defPPr>
-              <a:defRPr sz="3225" b="1">
-                <a:solidFill>
-                  <a:srgbClr val="F1F5F7"/>
-                </a:solidFill>
-                <a:latin typeface="Arial"/>
-                <a:ea typeface="Arial"/>
-                <a:cs typeface="Arial"/>
-              </a:defRPr>
-            </a:defPPr>
-          </a:lstStyle>
           <a:p xmlns:a="http://schemas.openxmlformats.org/drawingml/2006/main">
             <a:pPr>
-              <a:defRPr sz="3225" b="1">
-                <a:solidFill>
-                  <a:srgbClr val="F1F5F7"/>
+              <a:defRPr sz="2025" b="0">
+                <a:solidFill>
+                  <a:srgbClr val="B0BDC5"/>
                 </a:solidFill>
                 <a:latin typeface="Arial"/>
                 <a:ea typeface="Arial"/>
@@ -6346,83 +7529,15 @@
               </a:defRPr>
             </a:pPr>
             <a:r>
-              <a:rPr sz="3225" b="1">
-                <a:solidFill>
-                  <a:srgbClr val="F1F5F7"/>
+              <a:rPr sz="2025" b="0">
+                <a:solidFill>
+                  <a:srgbClr val="B0BDC5"/>
                 </a:solidFill>
                 <a:latin typeface="Arial"/>
                 <a:ea typeface="Arial"/>
                 <a:cs typeface="Arial"/>
               </a:rPr>
-              <a:t>PostgreSQL + Redis</a:t>
-            </a:r>
-          </a:p>
-        </p:txBody>
-      </p:sp>
-      <p:sp>
-        <p:nvSpPr>
-          <p:cNvPr id="7" name="">
-            <a:extLst xmlns:a="http://schemas.openxmlformats.org/drawingml/2006/main">
-              <a:ext uri="{FF2B5EF4-FFF2-40B4-BE49-F238E27FC236}">
-                <a16:creationId xmlns:a16="http://schemas.microsoft.com/office/drawing/2014/main" id="{F99CF46F-A6EB-4F67-9FC5-6A61F9CE75B0}"/>
-              </a:ext>
-            </a:extLst>
-          </p:cNvPr>
-          <p:cNvSpPr>
-            <a:spLocks xmlns:a="http://schemas.openxmlformats.org/drawingml/2006/main" noGrp="1"/>
-          </p:cNvSpPr>
-          <p:nvPr/>
-        </p:nvSpPr>
-        <p:spPr>
-          <a:xfrm xmlns:a="http://schemas.openxmlformats.org/drawingml/2006/main">
-            <a:off x="685800" y="5553075"/>
-            <a:ext cx="10382250" cy="523875"/>
-          </a:xfrm>
-          <a:prstGeom xmlns:a="http://schemas.openxmlformats.org/drawingml/2006/main" prst="rect">
-            <a:avLst/>
-          </a:prstGeom>
-          <a:noFill xmlns:a="http://schemas.openxmlformats.org/drawingml/2006/main"/>
-          <a:ln xmlns:a="http://schemas.openxmlformats.org/drawingml/2006/main" w="0">
-            <a:noFill/>
-          </a:ln>
-        </p:spPr>
-        <p:txBody>
-          <a:bodyPr xmlns:a="http://schemas.openxmlformats.org/drawingml/2006/main">
-            <a:noAutofit/>
-          </a:bodyPr>
-          <a:lstStyle xmlns:a="http://schemas.openxmlformats.org/drawingml/2006/main">
-            <a:defPPr>
-              <a:defRPr sz="2175" b="0">
-                <a:solidFill>
-                  <a:srgbClr val="B0BDC5"/>
-                </a:solidFill>
-                <a:latin typeface="Arial"/>
-                <a:ea typeface="Arial"/>
-                <a:cs typeface="Arial"/>
-              </a:defRPr>
-            </a:defPPr>
-          </a:lstStyle>
-          <a:p xmlns:a="http://schemas.openxmlformats.org/drawingml/2006/main">
-            <a:pPr>
-              <a:defRPr sz="2175" b="0">
-                <a:solidFill>
-                  <a:srgbClr val="B0BDC5"/>
-                </a:solidFill>
-                <a:latin typeface="Arial"/>
-                <a:ea typeface="Arial"/>
-                <a:cs typeface="Arial"/>
-              </a:defRPr>
-            </a:pPr>
-            <a:r>
-              <a:rPr sz="2175" b="0">
-                <a:solidFill>
-                  <a:srgbClr val="B0BDC5"/>
-                </a:solidFill>
-                <a:latin typeface="Arial"/>
-                <a:ea typeface="Arial"/>
-                <a:cs typeface="Arial"/>
-              </a:rPr>
-              <a:t>Результаты и правила в БД. Сессии и лимиты в Redis.</a:t>
+              <a:t>ещё требуют проверки экспертами и кандидатами.</a:t>
             </a:r>
           </a:p>
         </p:txBody>
@@ -6430,7 +7545,7 @@
     </p:spTree>
     <p:extLst>
       <p:ext uri="{BB962C8B-B14F-4D97-AF65-F5344CB8AC3E}">
-        <p14:creationId xmlns:p14="http://schemas.microsoft.com/office/powerpoint/2010/main" val="124663733"/>
+        <p14:creationId xmlns:p14="http://schemas.microsoft.com/office/powerpoint/2010/main" val="2031559651"/>
       </p:ext>
     </p:extLst>
   </p:cSld>
@@ -6458,10 +7573,10 @@
       </p:grpSpPr>
       <p:sp>
         <p:nvSpPr>
-          <p:cNvPr id="11" name="">
+          <p:cNvPr id="8" name="">
             <a:extLst xmlns:a="http://schemas.openxmlformats.org/drawingml/2006/main">
               <a:ext uri="{FF2B5EF4-FFF2-40B4-BE49-F238E27FC236}">
-                <a16:creationId xmlns:a16="http://schemas.microsoft.com/office/drawing/2014/main" id="{5F2285B8-8AC9-4FC5-A2D1-293702485998}"/>
+                <a16:creationId xmlns:a16="http://schemas.microsoft.com/office/drawing/2014/main" id="{4BC52809-34B1-47D1-8FF4-DF3719320A9B}"/>
               </a:ext>
             </a:extLst>
           </p:cNvPr>
@@ -6519,7 +7634,7 @@
                 <a:ea typeface="Arial"/>
                 <a:cs typeface="Arial"/>
               </a:rPr>
-              <a:t>Следующий этап</a:t>
+              <a:t>Проверка подбора</a:t>
             </a:r>
           </a:p>
         </p:txBody>
@@ -6529,7 +7644,7 @@
           <p:cNvPr id="2" name="">
             <a:extLst xmlns:a="http://schemas.openxmlformats.org/drawingml/2006/main">
               <a:ext uri="{FF2B5EF4-FFF2-40B4-BE49-F238E27FC236}">
-                <a16:creationId xmlns:a16="http://schemas.microsoft.com/office/drawing/2014/main" id="{AA097498-DCF6-49C3-8EEA-977DF1C7CF1E}"/>
+                <a16:creationId xmlns:a16="http://schemas.microsoft.com/office/drawing/2014/main" id="{66DC592B-32D8-4E0A-B150-C387E53370ED}"/>
               </a:ext>
             </a:extLst>
           </p:cNvPr>
@@ -6540,8 +7655,8 @@
         </p:nvSpPr>
         <p:spPr>
           <a:xfrm xmlns:a="http://schemas.openxmlformats.org/drawingml/2006/main">
-            <a:off x="685800" y="1504950"/>
-            <a:ext cx="742950" cy="647700"/>
+            <a:off x="685800" y="1638300"/>
+            <a:ext cx="5334000" cy="1200150"/>
           </a:xfrm>
           <a:prstGeom xmlns:a="http://schemas.openxmlformats.org/drawingml/2006/main" prst="rect">
             <a:avLst/>
@@ -6557,7 +7672,7 @@
           </a:bodyPr>
           <a:lstStyle xmlns:a="http://schemas.openxmlformats.org/drawingml/2006/main">
             <a:defPPr>
-              <a:defRPr sz="3150" b="1">
+              <a:defRPr sz="6900" b="1">
                 <a:solidFill>
                   <a:srgbClr val="7496FF"/>
                 </a:solidFill>
@@ -6569,7 +7684,7 @@
           </a:lstStyle>
           <a:p xmlns:a="http://schemas.openxmlformats.org/drawingml/2006/main">
             <a:pPr>
-              <a:defRPr sz="3150" b="1">
+              <a:defRPr sz="6900" b="1">
                 <a:solidFill>
                   <a:srgbClr val="7496FF"/>
                 </a:solidFill>
@@ -6579,7 +7694,7 @@
               </a:defRPr>
             </a:pPr>
             <a:r>
-              <a:rPr sz="3150" b="1">
+              <a:rPr sz="6900" b="1">
                 <a:solidFill>
                   <a:srgbClr val="7496FF"/>
                 </a:solidFill>
@@ -6587,7 +7702,7 @@
                 <a:ea typeface="Arial"/>
                 <a:cs typeface="Arial"/>
               </a:rPr>
-              <a:t>01</a:t>
+              <a:t>0,967</a:t>
             </a:r>
           </a:p>
         </p:txBody>
@@ -6597,7 +7712,7 @@
           <p:cNvPr id="3" name="">
             <a:extLst xmlns:a="http://schemas.openxmlformats.org/drawingml/2006/main">
               <a:ext uri="{FF2B5EF4-FFF2-40B4-BE49-F238E27FC236}">
-                <a16:creationId xmlns:a16="http://schemas.microsoft.com/office/drawing/2014/main" id="{D6656C51-A45E-4200-A7AA-6FE4DC4F2C78}"/>
+                <a16:creationId xmlns:a16="http://schemas.microsoft.com/office/drawing/2014/main" id="{21BBBCC1-FB35-4847-B42E-2FD0DEF6A9DC}"/>
               </a:ext>
             </a:extLst>
           </p:cNvPr>
@@ -6608,8 +7723,8 @@
         </p:nvSpPr>
         <p:spPr>
           <a:xfrm xmlns:a="http://schemas.openxmlformats.org/drawingml/2006/main">
-            <a:off x="1685925" y="1504950"/>
-            <a:ext cx="9525000" cy="457200"/>
+            <a:off x="723900" y="3105150"/>
+            <a:ext cx="4762500" cy="1047750"/>
           </a:xfrm>
           <a:prstGeom xmlns:a="http://schemas.openxmlformats.org/drawingml/2006/main" prst="rect">
             <a:avLst/>
@@ -6625,7 +7740,7 @@
           </a:bodyPr>
           <a:lstStyle xmlns:a="http://schemas.openxmlformats.org/drawingml/2006/main">
             <a:defPPr>
-              <a:defRPr sz="2250" b="1">
+              <a:defRPr sz="2550" b="0">
                 <a:solidFill>
                   <a:srgbClr val="F1F5F7"/>
                 </a:solidFill>
@@ -6637,7 +7752,7 @@
           </a:lstStyle>
           <a:p xmlns:a="http://schemas.openxmlformats.org/drawingml/2006/main">
             <a:pPr>
-              <a:defRPr sz="2250" b="1">
+              <a:defRPr sz="2550" b="0">
                 <a:solidFill>
                   <a:srgbClr val="F1F5F7"/>
                 </a:solidFill>
@@ -6647,7 +7762,7 @@
               </a:defRPr>
             </a:pPr>
             <a:r>
-              <a:rPr sz="2250" b="1">
+              <a:rPr sz="2550" b="0">
                 <a:solidFill>
                   <a:srgbClr val="F1F5F7"/>
                 </a:solidFill>
@@ -6655,7 +7770,30 @@
                 <a:ea typeface="Arial"/>
                 <a:cs typeface="Arial"/>
               </a:rPr>
-              <a:t>Экспертная калибровка</a:t>
+              <a:t>Precision@k</a:t>
+            </a:r>
+          </a:p>
+          <a:p xmlns:a="http://schemas.openxmlformats.org/drawingml/2006/main">
+            <a:pPr>
+              <a:defRPr sz="2550" b="0">
+                <a:solidFill>
+                  <a:srgbClr val="F1F5F7"/>
+                </a:solidFill>
+                <a:latin typeface="Arial"/>
+                <a:ea typeface="Arial"/>
+                <a:cs typeface="Arial"/>
+              </a:defRPr>
+            </a:pPr>
+            <a:r>
+              <a:rPr sz="2550" b="0">
+                <a:solidFill>
+                  <a:srgbClr val="F1F5F7"/>
+                </a:solidFill>
+                <a:latin typeface="Arial"/>
+                <a:ea typeface="Arial"/>
+                <a:cs typeface="Arial"/>
+              </a:rPr>
+              <a:t>с учётом стека</a:t>
             </a:r>
           </a:p>
         </p:txBody>
@@ -6665,7 +7803,7 @@
           <p:cNvPr id="4" name="">
             <a:extLst xmlns:a="http://schemas.openxmlformats.org/drawingml/2006/main">
               <a:ext uri="{FF2B5EF4-FFF2-40B4-BE49-F238E27FC236}">
-                <a16:creationId xmlns:a16="http://schemas.microsoft.com/office/drawing/2014/main" id="{5C7264A2-94E0-4BC5-95B6-9561667C02DB}"/>
+                <a16:creationId xmlns:a16="http://schemas.microsoft.com/office/drawing/2014/main" id="{560F50A4-5332-4D46-AFAD-3B7EAD70386D}"/>
               </a:ext>
             </a:extLst>
           </p:cNvPr>
@@ -6676,8 +7814,8 @@
         </p:nvSpPr>
         <p:spPr>
           <a:xfrm xmlns:a="http://schemas.openxmlformats.org/drawingml/2006/main">
-            <a:off x="1685925" y="2047875"/>
-            <a:ext cx="9525000" cy="781050"/>
+            <a:off x="6562725" y="1638300"/>
+            <a:ext cx="4762500" cy="1200150"/>
           </a:xfrm>
           <a:prstGeom xmlns:a="http://schemas.openxmlformats.org/drawingml/2006/main" prst="rect">
             <a:avLst/>
@@ -6693,9 +7831,9 @@
           </a:bodyPr>
           <a:lstStyle xmlns:a="http://schemas.openxmlformats.org/drawingml/2006/main">
             <a:defPPr>
-              <a:defRPr sz="1950" b="0">
-                <a:solidFill>
-                  <a:srgbClr val="B0BDC5"/>
+              <a:defRPr sz="6900" b="1">
+                <a:solidFill>
+                  <a:srgbClr val="F1F5F7"/>
                 </a:solidFill>
                 <a:latin typeface="Arial"/>
                 <a:ea typeface="Arial"/>
@@ -6705,9 +7843,9 @@
           </a:lstStyle>
           <a:p xmlns:a="http://schemas.openxmlformats.org/drawingml/2006/main">
             <a:pPr>
-              <a:defRPr sz="1950" b="0">
-                <a:solidFill>
-                  <a:srgbClr val="B0BDC5"/>
+              <a:defRPr sz="6900" b="1">
+                <a:solidFill>
+                  <a:srgbClr val="F1F5F7"/>
                 </a:solidFill>
                 <a:latin typeface="Arial"/>
                 <a:ea typeface="Arial"/>
@@ -6715,15 +7853,15 @@
               </a:defRPr>
             </a:pPr>
             <a:r>
-              <a:rPr sz="1950" b="0">
-                <a:solidFill>
-                  <a:srgbClr val="B0BDC5"/>
+              <a:rPr sz="6900" b="1">
+                <a:solidFill>
+                  <a:srgbClr val="F1F5F7"/>
                 </a:solidFill>
                 <a:latin typeface="Arial"/>
                 <a:ea typeface="Arial"/>
                 <a:cs typeface="Arial"/>
               </a:rPr>
-              <a:t>Расширение банка, независимая разметка грейдов и качества подбора.</a:t>
+              <a:t>0,833</a:t>
             </a:r>
           </a:p>
         </p:txBody>
@@ -6733,7 +7871,7 @@
           <p:cNvPr id="5" name="">
             <a:extLst xmlns:a="http://schemas.openxmlformats.org/drawingml/2006/main">
               <a:ext uri="{FF2B5EF4-FFF2-40B4-BE49-F238E27FC236}">
-                <a16:creationId xmlns:a16="http://schemas.microsoft.com/office/drawing/2014/main" id="{5D4D1F49-6EED-4C37-B4D0-E71E6EB8F973}"/>
+                <a16:creationId xmlns:a16="http://schemas.microsoft.com/office/drawing/2014/main" id="{F501D058-9258-4E80-8622-B3CD757A99FA}"/>
               </a:ext>
             </a:extLst>
           </p:cNvPr>
@@ -6744,8 +7882,8 @@
         </p:nvSpPr>
         <p:spPr>
           <a:xfrm xmlns:a="http://schemas.openxmlformats.org/drawingml/2006/main">
-            <a:off x="685800" y="3057525"/>
-            <a:ext cx="742950" cy="647700"/>
+            <a:off x="6600825" y="3105150"/>
+            <a:ext cx="4762500" cy="1047750"/>
           </a:xfrm>
           <a:prstGeom xmlns:a="http://schemas.openxmlformats.org/drawingml/2006/main" prst="rect">
             <a:avLst/>
@@ -6761,9 +7899,9 @@
           </a:bodyPr>
           <a:lstStyle xmlns:a="http://schemas.openxmlformats.org/drawingml/2006/main">
             <a:defPPr>
-              <a:defRPr sz="3150" b="1">
-                <a:solidFill>
-                  <a:srgbClr val="7496FF"/>
+              <a:defRPr sz="2550" b="0">
+                <a:solidFill>
+                  <a:srgbClr val="B0BDC5"/>
                 </a:solidFill>
                 <a:latin typeface="Arial"/>
                 <a:ea typeface="Arial"/>
@@ -6773,9 +7911,9 @@
           </a:lstStyle>
           <a:p xmlns:a="http://schemas.openxmlformats.org/drawingml/2006/main">
             <a:pPr>
-              <a:defRPr sz="3150" b="1">
-                <a:solidFill>
-                  <a:srgbClr val="7496FF"/>
+              <a:defRPr sz="2550" b="0">
+                <a:solidFill>
+                  <a:srgbClr val="B0BDC5"/>
                 </a:solidFill>
                 <a:latin typeface="Arial"/>
                 <a:ea typeface="Arial"/>
@@ -6783,15 +7921,38 @@
               </a:defRPr>
             </a:pPr>
             <a:r>
-              <a:rPr sz="3150" b="1">
-                <a:solidFill>
-                  <a:srgbClr val="7496FF"/>
+              <a:rPr sz="2550" b="0">
+                <a:solidFill>
+                  <a:srgbClr val="B0BDC5"/>
                 </a:solidFill>
                 <a:latin typeface="Arial"/>
                 <a:ea typeface="Arial"/>
                 <a:cs typeface="Arial"/>
               </a:rPr>
-              <a:t>02</a:t>
+              <a:t>Только балл теста</a:t>
+            </a:r>
+          </a:p>
+          <a:p xmlns:a="http://schemas.openxmlformats.org/drawingml/2006/main">
+            <a:pPr>
+              <a:defRPr sz="2550" b="0">
+                <a:solidFill>
+                  <a:srgbClr val="B0BDC5"/>
+                </a:solidFill>
+                <a:latin typeface="Arial"/>
+                <a:ea typeface="Arial"/>
+                <a:cs typeface="Arial"/>
+              </a:defRPr>
+            </a:pPr>
+            <a:r>
+              <a:rPr sz="2550" b="0">
+                <a:solidFill>
+                  <a:srgbClr val="B0BDC5"/>
+                </a:solidFill>
+                <a:latin typeface="Arial"/>
+                <a:ea typeface="Arial"/>
+                <a:cs typeface="Arial"/>
+              </a:rPr>
+              <a:t>при тех же фильтрах</a:t>
             </a:r>
           </a:p>
         </p:txBody>
@@ -6801,7 +7962,7 @@
           <p:cNvPr id="6" name="">
             <a:extLst xmlns:a="http://schemas.openxmlformats.org/drawingml/2006/main">
               <a:ext uri="{FF2B5EF4-FFF2-40B4-BE49-F238E27FC236}">
-                <a16:creationId xmlns:a16="http://schemas.microsoft.com/office/drawing/2014/main" id="{705BC36A-6408-4196-A43C-BB478D8C1546}"/>
+                <a16:creationId xmlns:a16="http://schemas.microsoft.com/office/drawing/2014/main" id="{3B2E3FF2-D395-49E1-8E2E-6606488B82A5}"/>
               </a:ext>
             </a:extLst>
           </p:cNvPr>
@@ -6812,8 +7973,8 @@
         </p:nvSpPr>
         <p:spPr>
           <a:xfrm xmlns:a="http://schemas.openxmlformats.org/drawingml/2006/main">
-            <a:off x="1685925" y="3057525"/>
-            <a:ext cx="9525000" cy="457200"/>
+            <a:off x="723900" y="4781550"/>
+            <a:ext cx="10477500" cy="523875"/>
           </a:xfrm>
           <a:prstGeom xmlns:a="http://schemas.openxmlformats.org/drawingml/2006/main" prst="rect">
             <a:avLst/>
@@ -6829,7 +7990,7 @@
           </a:bodyPr>
           <a:lstStyle xmlns:a="http://schemas.openxmlformats.org/drawingml/2006/main">
             <a:defPPr>
-              <a:defRPr sz="2250" b="1">
+              <a:defRPr sz="2175" b="0">
                 <a:solidFill>
                   <a:srgbClr val="F1F5F7"/>
                 </a:solidFill>
@@ -6841,7 +8002,7 @@
           </a:lstStyle>
           <a:p xmlns:a="http://schemas.openxmlformats.org/drawingml/2006/main">
             <a:pPr>
-              <a:defRPr sz="2250" b="1">
+              <a:defRPr sz="2175" b="0">
                 <a:solidFill>
                   <a:srgbClr val="F1F5F7"/>
                 </a:solidFill>
@@ -6851,7 +8012,7 @@
               </a:defRPr>
             </a:pPr>
             <a:r>
-              <a:rPr sz="2250" b="1">
+              <a:rPr sz="2175" b="0">
                 <a:solidFill>
                   <a:srgbClr val="F1F5F7"/>
                 </a:solidFill>
@@ -6859,7 +8020,7 @@
                 <a:ea typeface="Arial"/>
                 <a:cs typeface="Arial"/>
               </a:rPr>
-              <a:t>Интеграции</a:t>
+              <a:t>12 профилей и 15 запросов с ручной разметкой.</a:t>
             </a:r>
           </a:p>
         </p:txBody>
@@ -6869,7 +8030,7 @@
           <p:cNvPr id="7" name="">
             <a:extLst xmlns:a="http://schemas.openxmlformats.org/drawingml/2006/main">
               <a:ext uri="{FF2B5EF4-FFF2-40B4-BE49-F238E27FC236}">
-                <a16:creationId xmlns:a16="http://schemas.microsoft.com/office/drawing/2014/main" id="{3D57F367-F928-49FA-8B67-EF217660A00A}"/>
+                <a16:creationId xmlns:a16="http://schemas.microsoft.com/office/drawing/2014/main" id="{D5B9F098-9EF6-4E03-899B-8BBEDE666655}"/>
               </a:ext>
             </a:extLst>
           </p:cNvPr>
@@ -6880,8 +8041,8 @@
         </p:nvSpPr>
         <p:spPr>
           <a:xfrm xmlns:a="http://schemas.openxmlformats.org/drawingml/2006/main">
-            <a:off x="1685925" y="3600450"/>
-            <a:ext cx="9525000" cy="781050"/>
+            <a:off x="723900" y="5600700"/>
+            <a:ext cx="10477500" cy="847725"/>
           </a:xfrm>
           <a:prstGeom xmlns:a="http://schemas.openxmlformats.org/drawingml/2006/main" prst="rect">
             <a:avLst/>
@@ -6897,7 +8058,7 @@
           </a:bodyPr>
           <a:lstStyle xmlns:a="http://schemas.openxmlformats.org/drawingml/2006/main">
             <a:defPPr>
-              <a:defRPr sz="1950" b="0">
+              <a:defRPr sz="2025" b="0">
                 <a:solidFill>
                   <a:srgbClr val="B0BDC5"/>
                 </a:solidFill>
@@ -6909,7 +8070,7 @@
           </a:lstStyle>
           <a:p xmlns:a="http://schemas.openxmlformats.org/drawingml/2006/main">
             <a:pPr>
-              <a:defRPr sz="1950" b="0">
+              <a:defRPr sz="2025" b="0">
                 <a:solidFill>
                   <a:srgbClr val="B0BDC5"/>
                 </a:solidFill>
@@ -6919,7 +8080,7 @@
               </a:defRPr>
             </a:pPr>
             <a:r>
-              <a:rPr sz="1950" b="0">
+              <a:rPr sz="2025" b="0">
                 <a:solidFill>
                   <a:srgbClr val="B0BDC5"/>
                 </a:solidFill>
@@ -6927,17 +8088,69 @@
                 <a:ea typeface="Arial"/>
                 <a:cs typeface="Arial"/>
               </a:rPr>
-              <a:t>ФСП ID через OIDC, контракт достижений и события для ATS.</a:t>
+              <a:t>Синтетический набор разработки. Независимая проверка</a:t>
             </a:r>
           </a:p>
-        </p:txBody>
-      </p:sp>
-      <p:sp>
-        <p:nvSpPr>
-          <p:cNvPr id="8" name="">
+          <a:p xmlns:a="http://schemas.openxmlformats.org/drawingml/2006/main">
+            <a:pPr>
+              <a:defRPr sz="2025" b="0">
+                <a:solidFill>
+                  <a:srgbClr val="B0BDC5"/>
+                </a:solidFill>
+                <a:latin typeface="Arial"/>
+                <a:ea typeface="Arial"/>
+                <a:cs typeface="Arial"/>
+              </a:defRPr>
+            </a:pPr>
+            <a:r>
+              <a:rPr sz="2025" b="0">
+                <a:solidFill>
+                  <a:srgbClr val="B0BDC5"/>
+                </a:solidFill>
+                <a:latin typeface="Arial"/>
+                <a:ea typeface="Arial"/>
+                <a:cs typeface="Arial"/>
+              </a:rPr>
+              <a:t>с экспертами и реальными пользователями ещё впереди.</a:t>
+            </a:r>
+          </a:p>
+        </p:txBody>
+      </p:sp>
+    </p:spTree>
+    <p:extLst>
+      <p:ext uri="{BB962C8B-B14F-4D97-AF65-F5344CB8AC3E}">
+        <p14:creationId xmlns:p14="http://schemas.microsoft.com/office/powerpoint/2010/main" val="1418320021"/>
+      </p:ext>
+    </p:extLst>
+  </p:cSld>
+</p:sld>
+</file>
+
+<file path=ppt/slides/slide9.xml><?xml version="1.0" encoding="utf-8"?>
+<p:sld xmlns:p="http://schemas.openxmlformats.org/presentationml/2006/main">
+  <p:cSld>
+    <p:bg>
+      <p:bgPr>
+        <a:solidFill xmlns:a="http://schemas.openxmlformats.org/drawingml/2006/main">
+          <a:srgbClr val="11181C"/>
+        </a:solidFill>
+      </p:bgPr>
+    </p:bg>
+    <p:spTree>
+      <p:nvGrpSpPr>
+        <p:cNvPr id="1" name=""/>
+        <p:cNvGrpSpPr/>
+        <p:nvPr/>
+      </p:nvGrpSpPr>
+      <p:grpSpPr>
+        <a:xfrm xmlns:a="http://schemas.openxmlformats.org/drawingml/2006/main"/>
+      </p:grpSpPr>
+      <p:sp>
+        <p:nvSpPr>
+          <p:cNvPr id="4" name="">
             <a:extLst xmlns:a="http://schemas.openxmlformats.org/drawingml/2006/main">
               <a:ext uri="{FF2B5EF4-FFF2-40B4-BE49-F238E27FC236}">
-                <a16:creationId xmlns:a16="http://schemas.microsoft.com/office/drawing/2014/main" id="{5DD608BF-C3EB-4262-A754-F96999304E35}"/>
+                <a16:creationId xmlns:a16="http://schemas.microsoft.com/office/drawing/2014/main" id="{BCD12067-B354-4586-B732-0CDDFA3DEBB8}"/>
               </a:ext>
             </a:extLst>
           </p:cNvPr>
@@ -6948,8 +8161,8 @@
         </p:nvSpPr>
         <p:spPr>
           <a:xfrm xmlns:a="http://schemas.openxmlformats.org/drawingml/2006/main">
-            <a:off x="685800" y="4610100"/>
-            <a:ext cx="742950" cy="647700"/>
+            <a:off x="666750" y="457200"/>
+            <a:ext cx="10820400" cy="857250"/>
           </a:xfrm>
           <a:prstGeom xmlns:a="http://schemas.openxmlformats.org/drawingml/2006/main" prst="rect">
             <a:avLst/>
@@ -6965,9 +8178,9 @@
           </a:bodyPr>
           <a:lstStyle xmlns:a="http://schemas.openxmlformats.org/drawingml/2006/main">
             <a:defPPr>
-              <a:defRPr sz="3150" b="1">
-                <a:solidFill>
-                  <a:srgbClr val="7496FF"/>
+              <a:defRPr sz="3300" b="1">
+                <a:solidFill>
+                  <a:srgbClr val="F1F5F7"/>
                 </a:solidFill>
                 <a:latin typeface="Arial"/>
                 <a:ea typeface="Arial"/>
@@ -6977,9 +8190,9 @@
           </a:lstStyle>
           <a:p xmlns:a="http://schemas.openxmlformats.org/drawingml/2006/main">
             <a:pPr>
-              <a:defRPr sz="3150" b="1">
-                <a:solidFill>
-                  <a:srgbClr val="7496FF"/>
+              <a:defRPr sz="3300" b="1">
+                <a:solidFill>
+                  <a:srgbClr val="F1F5F7"/>
                 </a:solidFill>
                 <a:latin typeface="Arial"/>
                 <a:ea typeface="Arial"/>
@@ -6987,37 +8200,65 @@
               </a:defRPr>
             </a:pPr>
             <a:r>
-              <a:rPr sz="3150" b="1">
-                <a:solidFill>
-                  <a:srgbClr val="7496FF"/>
+              <a:rPr sz="3300" b="1">
+                <a:solidFill>
+                  <a:srgbClr val="F1F5F7"/>
                 </a:solidFill>
                 <a:latin typeface="Arial"/>
                 <a:ea typeface="Arial"/>
                 <a:cs typeface="Arial"/>
               </a:rPr>
-              <a:t>03</a:t>
+              <a:t>Вакансии и отклики</a:t>
             </a:r>
           </a:p>
         </p:txBody>
       </p:sp>
-      <p:sp>
-        <p:nvSpPr>
-          <p:cNvPr id="9" name="">
+      <p:pic>
+        <p:nvPicPr>
+          <p:cNvPr id="2" name="">
             <a:extLst xmlns:a="http://schemas.openxmlformats.org/drawingml/2006/main">
               <a:ext uri="{FF2B5EF4-FFF2-40B4-BE49-F238E27FC236}">
-                <a16:creationId xmlns:a16="http://schemas.microsoft.com/office/drawing/2014/main" id="{C2B18EC7-448F-4F17-AB3A-ADD9FF029764}"/>
+                <a16:creationId xmlns:a16="http://schemas.microsoft.com/office/drawing/2014/main" id="{56FFE486-04E6-4618-BEE0-477F28AAE7A9}"/>
               </a:ext>
             </a:extLst>
           </p:cNvPr>
-          <p:cNvSpPr>
-            <a:spLocks xmlns:a="http://schemas.openxmlformats.org/drawingml/2006/main" noGrp="1"/>
-          </p:cNvSpPr>
+          <p:cNvPicPr>
+            <a:picLocks xmlns:a="http://schemas.openxmlformats.org/drawingml/2006/main" noChangeAspect="1"/>
+          </p:cNvPicPr>
           <p:nvPr/>
-        </p:nvSpPr>
+        </p:nvPicPr>
+        <p:blipFill>
+          <a:blip xmlns:r="http://schemas.openxmlformats.org/officeDocument/2006/relationships" xmlns:a="http://schemas.openxmlformats.org/drawingml/2006/main" r:embed="R759fb02eca194197"/>
+          <a:stretch xmlns:a="http://schemas.openxmlformats.org/drawingml/2006/main"/>
+        </p:blipFill>
         <p:spPr>
           <a:xfrm xmlns:a="http://schemas.openxmlformats.org/drawingml/2006/main">
-            <a:off x="1685925" y="4610100"/>
-            <a:ext cx="9525000" cy="457200"/>
+            <a:off x="2735580" y="1447800"/>
+            <a:ext cx="6720840" cy="4667250"/>
+          </a:xfrm>
+          <a:prstGeom xmlns:a="http://schemas.openxmlformats.org/drawingml/2006/main" prst="rect">
+            <a:avLst/>
+          </a:prstGeom>
+        </p:spPr>
+      </p:pic>
+      <p:sp>
+        <p:nvSpPr>
+          <p:cNvPr id="3" name="">
+            <a:extLst xmlns:a="http://schemas.openxmlformats.org/drawingml/2006/main">
+              <a:ext uri="{FF2B5EF4-FFF2-40B4-BE49-F238E27FC236}">
+                <a16:creationId xmlns:a16="http://schemas.microsoft.com/office/drawing/2014/main" id="{50FF313B-59BD-409F-AC0F-73304AFA5661}"/>
+              </a:ext>
+            </a:extLst>
+          </p:cNvPr>
+          <p:cNvSpPr>
+            <a:spLocks xmlns:a="http://schemas.openxmlformats.org/drawingml/2006/main" noGrp="1"/>
+          </p:cNvSpPr>
+          <p:nvPr/>
+        </p:nvSpPr>
+        <p:spPr>
+          <a:xfrm xmlns:a="http://schemas.openxmlformats.org/drawingml/2006/main">
+            <a:off x="685800" y="6296025"/>
+            <a:ext cx="10572750" cy="285750"/>
           </a:xfrm>
           <a:prstGeom xmlns:a="http://schemas.openxmlformats.org/drawingml/2006/main" prst="rect">
             <a:avLst/>
@@ -7033,9 +8274,9 @@
           </a:bodyPr>
           <a:lstStyle xmlns:a="http://schemas.openxmlformats.org/drawingml/2006/main">
             <a:defPPr>
-              <a:defRPr sz="2250" b="1">
-                <a:solidFill>
-                  <a:srgbClr val="F1F5F7"/>
+              <a:defRPr sz="1725" b="0">
+                <a:solidFill>
+                  <a:srgbClr val="B0BDC5"/>
                 </a:solidFill>
                 <a:latin typeface="Arial"/>
                 <a:ea typeface="Arial"/>
@@ -7045,9 +8286,9 @@
           </a:lstStyle>
           <a:p xmlns:a="http://schemas.openxmlformats.org/drawingml/2006/main">
             <a:pPr>
-              <a:defRPr sz="2250" b="1">
-                <a:solidFill>
-                  <a:srgbClr val="F1F5F7"/>
+              <a:defRPr sz="1725" b="0">
+                <a:solidFill>
+                  <a:srgbClr val="B0BDC5"/>
                 </a:solidFill>
                 <a:latin typeface="Arial"/>
                 <a:ea typeface="Arial"/>
@@ -7055,83 +8296,15 @@
               </a:defRPr>
             </a:pPr>
             <a:r>
-              <a:rPr sz="2250" b="1">
-                <a:solidFill>
-                  <a:srgbClr val="F1F5F7"/>
+              <a:rPr sz="1725" b="0">
+                <a:solidFill>
+                  <a:srgbClr val="B0BDC5"/>
                 </a:solidFill>
                 <a:latin typeface="Arial"/>
                 <a:ea typeface="Arial"/>
                 <a:cs typeface="Arial"/>
               </a:rPr>
-              <a:t>Внешний стенд</a:t>
-            </a:r>
-          </a:p>
-        </p:txBody>
-      </p:sp>
-      <p:sp>
-        <p:nvSpPr>
-          <p:cNvPr id="10" name="">
-            <a:extLst xmlns:a="http://schemas.openxmlformats.org/drawingml/2006/main">
-              <a:ext uri="{FF2B5EF4-FFF2-40B4-BE49-F238E27FC236}">
-                <a16:creationId xmlns:a16="http://schemas.microsoft.com/office/drawing/2014/main" id="{21744843-79B8-4B35-9656-AEC414A07921}"/>
-              </a:ext>
-            </a:extLst>
-          </p:cNvPr>
-          <p:cNvSpPr>
-            <a:spLocks xmlns:a="http://schemas.openxmlformats.org/drawingml/2006/main" noGrp="1"/>
-          </p:cNvSpPr>
-          <p:nvPr/>
-        </p:nvSpPr>
-        <p:spPr>
-          <a:xfrm xmlns:a="http://schemas.openxmlformats.org/drawingml/2006/main">
-            <a:off x="1685925" y="5153025"/>
-            <a:ext cx="9525000" cy="781050"/>
-          </a:xfrm>
-          <a:prstGeom xmlns:a="http://schemas.openxmlformats.org/drawingml/2006/main" prst="rect">
-            <a:avLst/>
-          </a:prstGeom>
-          <a:noFill xmlns:a="http://schemas.openxmlformats.org/drawingml/2006/main"/>
-          <a:ln xmlns:a="http://schemas.openxmlformats.org/drawingml/2006/main" w="0">
-            <a:noFill/>
-          </a:ln>
-        </p:spPr>
-        <p:txBody>
-          <a:bodyPr xmlns:a="http://schemas.openxmlformats.org/drawingml/2006/main">
-            <a:noAutofit/>
-          </a:bodyPr>
-          <a:lstStyle xmlns:a="http://schemas.openxmlformats.org/drawingml/2006/main">
-            <a:defPPr>
-              <a:defRPr sz="1950" b="0">
-                <a:solidFill>
-                  <a:srgbClr val="B0BDC5"/>
-                </a:solidFill>
-                <a:latin typeface="Arial"/>
-                <a:ea typeface="Arial"/>
-                <a:cs typeface="Arial"/>
-              </a:defRPr>
-            </a:defPPr>
-          </a:lstStyle>
-          <a:p xmlns:a="http://schemas.openxmlformats.org/drawingml/2006/main">
-            <a:pPr>
-              <a:defRPr sz="1950" b="0">
-                <a:solidFill>
-                  <a:srgbClr val="B0BDC5"/>
-                </a:solidFill>
-                <a:latin typeface="Arial"/>
-                <a:ea typeface="Arial"/>
-                <a:cs typeface="Arial"/>
-              </a:defRPr>
-            </a:pPr>
-            <a:r>
-              <a:rPr sz="1950" b="0">
-                <a:solidFill>
-                  <a:srgbClr val="B0BDC5"/>
-                </a:solidFill>
-                <a:latin typeface="Arial"/>
-                <a:ea typeface="Arial"/>
-                <a:cs typeface="Arial"/>
-              </a:rPr>
-              <a:t>Домен, HTTPS, почтовый сервис и база без демоаккаунтов.</a:t>
+              <a:t>Отклик дополняет обратный найм. Кандидат явно разрешает контакт.</a:t>
             </a:r>
           </a:p>
         </p:txBody>
@@ -7139,7 +8312,7 @@
     </p:spTree>
     <p:extLst>
       <p:ext uri="{BB962C8B-B14F-4D97-AF65-F5344CB8AC3E}">
-        <p14:creationId xmlns:p14="http://schemas.microsoft.com/office/powerpoint/2010/main" val="953333255"/>
+        <p14:creationId xmlns:p14="http://schemas.microsoft.com/office/powerpoint/2010/main" val="1657646493"/>
       </p:ext>
     </p:extLst>
   </p:cSld>

</xml_diff>